<commit_message>
Aplicar diseño por agencia (opción 2) en la diapositiva 2
Co-Authored-By: Claude Opus 5.5 <noreply@anthropic.com>
Claude-Session: https://claude.ai/code/session_01TzBdxGLNtSJLpCACAm6ryx
</commit_message>
<xml_diff>
--- a/Comparativo_Agencias_Septiembre_2026.pptx
+++ b/Comparativo_Agencias_Septiembre_2026.pptx
@@ -3630,1914 +3630,2484 @@
           </a:p>
         </p:txBody>
       </p:sp>
-      <p:graphicFrame>
-        <p:nvGraphicFramePr>
-          <p:cNvPr id="7" name="Tabla 2"/>
-          <p:cNvGraphicFramePr>
-            <a:graphicFrameLocks noGrp="1"/>
-          </p:cNvGraphicFramePr>
+      <p:sp>
+        <p:nvSpPr>
+          <p:cNvPr id="7" name="Agencia Central"/>
+          <p:cNvSpPr/>
           <p:nvPr/>
-        </p:nvGraphicFramePr>
-        <p:xfrm>
-          <a:off x="476250" y="1381125"/>
-          <a:ext cx="11247120" cy="4361688"/>
-        </p:xfrm>
-        <a:graphic>
-          <a:graphicData uri="http://schemas.openxmlformats.org/drawingml/2006/table">
-            <a:tbl>
-              <a:tblPr firstRow="0" bandRow="0"/>
-              <a:tblGrid>
-                <a:gridCol w="2148840"/>
-                <a:gridCol w="4343400"/>
-                <a:gridCol w="2377440"/>
-                <a:gridCol w="2377440"/>
-              </a:tblGrid>
-              <a:tr h="384048">
-                <a:tc>
-                  <a:txBody>
-                    <a:bodyPr/>
-                    <a:lstStyle/>
-                    <a:p>
-                      <a:pPr algn="l"/>
-                      <a:r>
-                        <a:rPr sz="1600" b="1">
-                          <a:solidFill>
-                            <a:srgbClr val="FFFFFF"/>
-                          </a:solidFill>
-                          <a:latin typeface="Nimbus Sans"/>
-                          <a:ea typeface="Nimbus Sans"/>
-                          <a:cs typeface="Nimbus Sans"/>
-                        </a:rPr>
-                        <a:t>Etapa</a:t>
-                      </a:r>
-                    </a:p>
-                  </a:txBody>
-                  <a:tcPr marL="109728" marR="109728" marT="27432" marB="27432" anchor="ctr">
-                    <a:lnL w="0">
-                      <a:noFill/>
-                    </a:lnL>
-                    <a:lnR w="0">
-                      <a:noFill/>
-                    </a:lnR>
-                    <a:lnT w="0">
-                      <a:noFill/>
-                    </a:lnT>
-                    <a:lnB w="0">
-                      <a:noFill/>
-                    </a:lnB>
-                    <a:solidFill>
-                      <a:srgbClr val="12304D"/>
-                    </a:solidFill>
-                  </a:tcPr>
-                </a:tc>
-                <a:tc>
-                  <a:txBody>
-                    <a:bodyPr/>
-                    <a:lstStyle/>
-                    <a:p>
-                      <a:pPr algn="l"/>
-                      <a:r>
-                        <a:rPr sz="1600" b="1">
-                          <a:solidFill>
-                            <a:srgbClr val="FFFFFF"/>
-                          </a:solidFill>
-                          <a:latin typeface="Nimbus Sans"/>
-                          <a:ea typeface="Nimbus Sans"/>
-                          <a:cs typeface="Nimbus Sans"/>
-                        </a:rPr>
-                        <a:t>Indicador</a:t>
-                      </a:r>
-                    </a:p>
-                  </a:txBody>
-                  <a:tcPr marL="109728" marR="109728" marT="27432" marB="27432" anchor="ctr">
-                    <a:lnL w="0">
-                      <a:noFill/>
-                    </a:lnL>
-                    <a:lnR w="0">
-                      <a:noFill/>
-                    </a:lnR>
-                    <a:lnT w="0">
-                      <a:noFill/>
-                    </a:lnT>
-                    <a:lnB w="0">
-                      <a:noFill/>
-                    </a:lnB>
-                    <a:solidFill>
-                      <a:srgbClr val="12304D"/>
-                    </a:solidFill>
-                  </a:tcPr>
-                </a:tc>
-                <a:tc>
-                  <a:txBody>
-                    <a:bodyPr/>
-                    <a:lstStyle/>
-                    <a:p>
-                      <a:pPr algn="r"/>
-                      <a:r>
-                        <a:rPr sz="1600" b="1">
-                          <a:solidFill>
-                            <a:srgbClr val="FFFFFF"/>
-                          </a:solidFill>
-                          <a:latin typeface="Nimbus Sans"/>
-                          <a:ea typeface="Nimbus Sans"/>
-                          <a:cs typeface="Nimbus Sans"/>
-                        </a:rPr>
-                        <a:t>Central</a:t>
-                      </a:r>
-                    </a:p>
-                  </a:txBody>
-                  <a:tcPr marL="109728" marR="109728" marT="27432" marB="27432" anchor="ctr">
-                    <a:lnL w="0">
-                      <a:noFill/>
-                    </a:lnL>
-                    <a:lnR w="0">
-                      <a:noFill/>
-                    </a:lnR>
-                    <a:lnT w="0">
-                      <a:noFill/>
-                    </a:lnT>
-                    <a:lnB w="0">
-                      <a:noFill/>
-                    </a:lnB>
-                    <a:solidFill>
-                      <a:srgbClr val="12304D"/>
-                    </a:solidFill>
-                  </a:tcPr>
-                </a:tc>
-                <a:tc>
-                  <a:txBody>
-                    <a:bodyPr/>
-                    <a:lstStyle/>
-                    <a:p>
-                      <a:pPr algn="r"/>
-                      <a:r>
-                        <a:rPr sz="1600" b="1">
-                          <a:solidFill>
-                            <a:srgbClr val="FFFFFF"/>
-                          </a:solidFill>
-                          <a:latin typeface="Nimbus Sans"/>
-                          <a:ea typeface="Nimbus Sans"/>
-                          <a:cs typeface="Nimbus Sans"/>
-                        </a:rPr>
-                        <a:t>Colegio Médico</a:t>
-                      </a:r>
-                    </a:p>
-                  </a:txBody>
-                  <a:tcPr marL="109728" marR="109728" marT="27432" marB="27432" anchor="ctr">
-                    <a:lnL w="0">
-                      <a:noFill/>
-                    </a:lnL>
-                    <a:lnR w="0">
-                      <a:noFill/>
-                    </a:lnR>
-                    <a:lnT w="0">
-                      <a:noFill/>
-                    </a:lnT>
-                    <a:lnB w="0">
-                      <a:noFill/>
-                    </a:lnB>
-                    <a:solidFill>
-                      <a:srgbClr val="12304D"/>
-                    </a:solidFill>
-                  </a:tcPr>
-                </a:tc>
-              </a:tr>
-              <a:tr h="338328">
-                <a:tc rowSpan="3">
-                  <a:txBody>
-                    <a:bodyPr wrap="square"/>
-                    <a:lstStyle/>
-                    <a:p>
-                      <a:pPr algn="l"/>
-                      <a:r>
-                        <a:rPr sz="1500" b="1">
-                          <a:solidFill>
-                            <a:srgbClr val="12304D"/>
-                          </a:solidFill>
-                          <a:latin typeface="Nimbus Sans"/>
-                          <a:ea typeface="Nimbus Sans"/>
-                          <a:cs typeface="Nimbus Sans"/>
-                        </a:rPr>
-                        <a:t>1. Desembolsos</a:t>
-                      </a:r>
-                    </a:p>
-                  </a:txBody>
-                  <a:tcPr marL="109728" marR="109728" marT="27432" marB="27432" anchor="ctr">
-                    <a:lnL w="0">
-                      <a:noFill/>
-                    </a:lnL>
-                    <a:lnR w="0">
-                      <a:noFill/>
-                    </a:lnR>
-                    <a:lnT w="0">
-                      <a:noFill/>
-                    </a:lnT>
-                    <a:lnB w="0">
-                      <a:noFill/>
-                    </a:lnB>
-                    <a:solidFill>
-                      <a:srgbClr val="F3F6F9"/>
-                    </a:solidFill>
-                  </a:tcPr>
-                </a:tc>
-                <a:tc>
-                  <a:txBody>
-                    <a:bodyPr/>
-                    <a:lstStyle/>
-                    <a:p>
-                      <a:pPr algn="l"/>
-                      <a:r>
-                        <a:rPr sz="1500" b="0">
-                          <a:solidFill>
-                            <a:srgbClr val="4A5A6A"/>
-                          </a:solidFill>
-                          <a:latin typeface="Nimbus Sans"/>
-                          <a:ea typeface="Nimbus Sans"/>
-                          <a:cs typeface="Nimbus Sans"/>
-                        </a:rPr>
-                        <a:t>Meta de desembolsos</a:t>
-                      </a:r>
-                    </a:p>
-                  </a:txBody>
-                  <a:tcPr marL="109728" marR="109728" marT="27432" marB="27432" anchor="ctr">
-                    <a:lnL w="0">
-                      <a:noFill/>
-                    </a:lnL>
-                    <a:lnR w="0">
-                      <a:noFill/>
-                    </a:lnR>
-                    <a:lnT w="0">
-                      <a:noFill/>
-                    </a:lnT>
-                    <a:lnB w="9525">
-                      <a:solidFill>
-                        <a:srgbClr val="D5DEE7"/>
-                      </a:solidFill>
-                    </a:lnB>
-                    <a:noFill/>
-                  </a:tcPr>
-                </a:tc>
-                <a:tc>
-                  <a:txBody>
-                    <a:bodyPr/>
-                    <a:lstStyle/>
-                    <a:p>
-                      <a:pPr algn="r"/>
-                      <a:r>
-                        <a:rPr sz="1500" b="0">
-                          <a:solidFill>
-                            <a:srgbClr val="4A5A6A"/>
-                          </a:solidFill>
-                          <a:latin typeface="Nimbus Sans"/>
-                          <a:ea typeface="Nimbus Sans"/>
-                          <a:cs typeface="Nimbus Sans"/>
-                        </a:rPr>
-                        <a:t>$8,100,000.00</a:t>
-                      </a:r>
-                    </a:p>
-                  </a:txBody>
-                  <a:tcPr marL="109728" marR="109728" marT="27432" marB="27432" anchor="ctr">
-                    <a:lnL w="0">
-                      <a:noFill/>
-                    </a:lnL>
-                    <a:lnR w="0">
-                      <a:noFill/>
-                    </a:lnR>
-                    <a:lnT w="0">
-                      <a:noFill/>
-                    </a:lnT>
-                    <a:lnB w="9525">
-                      <a:solidFill>
-                        <a:srgbClr val="D5DEE7"/>
-                      </a:solidFill>
-                    </a:lnB>
-                    <a:noFill/>
-                  </a:tcPr>
-                </a:tc>
-                <a:tc>
-                  <a:txBody>
-                    <a:bodyPr/>
-                    <a:lstStyle/>
-                    <a:p>
-                      <a:pPr algn="r"/>
-                      <a:r>
-                        <a:rPr sz="1500" b="0">
-                          <a:solidFill>
-                            <a:srgbClr val="4A5A6A"/>
-                          </a:solidFill>
-                          <a:latin typeface="Nimbus Sans"/>
-                          <a:ea typeface="Nimbus Sans"/>
-                          <a:cs typeface="Nimbus Sans"/>
-                        </a:rPr>
-                        <a:t>$5,625,000.00</a:t>
-                      </a:r>
-                    </a:p>
-                  </a:txBody>
-                  <a:tcPr marL="109728" marR="109728" marT="27432" marB="27432" anchor="ctr">
-                    <a:lnL w="0">
-                      <a:noFill/>
-                    </a:lnL>
-                    <a:lnR w="0">
-                      <a:noFill/>
-                    </a:lnR>
-                    <a:lnT w="0">
-                      <a:noFill/>
-                    </a:lnT>
-                    <a:lnB w="9525">
-                      <a:solidFill>
-                        <a:srgbClr val="D5DEE7"/>
-                      </a:solidFill>
-                    </a:lnB>
-                    <a:noFill/>
-                  </a:tcPr>
-                </a:tc>
-              </a:tr>
-              <a:tr h="338328">
-                <a:tc vMerge="1">
-                  <a:txBody>
-                    <a:bodyPr/>
-                    <a:lstStyle/>
-                    <a:p/>
-                  </a:txBody>
-                  <a:tcPr/>
-                </a:tc>
-                <a:tc>
-                  <a:txBody>
-                    <a:bodyPr/>
-                    <a:lstStyle/>
-                    <a:p>
-                      <a:pPr algn="l"/>
-                      <a:r>
-                        <a:rPr sz="1500" b="0">
-                          <a:solidFill>
-                            <a:srgbClr val="4A5A6A"/>
-                          </a:solidFill>
-                          <a:latin typeface="Nimbus Sans"/>
-                          <a:ea typeface="Nimbus Sans"/>
-                          <a:cs typeface="Nimbus Sans"/>
-                        </a:rPr>
-                        <a:t>Desembolsos realizados (+)</a:t>
-                      </a:r>
-                    </a:p>
-                  </a:txBody>
-                  <a:tcPr marL="109728" marR="109728" marT="27432" marB="27432" anchor="ctr">
-                    <a:lnL w="0">
-                      <a:noFill/>
-                    </a:lnL>
-                    <a:lnR w="0">
-                      <a:noFill/>
-                    </a:lnR>
-                    <a:lnT w="0">
-                      <a:noFill/>
-                    </a:lnT>
-                    <a:lnB w="9525">
-                      <a:solidFill>
-                        <a:srgbClr val="D5DEE7"/>
-                      </a:solidFill>
-                    </a:lnB>
-                    <a:noFill/>
-                  </a:tcPr>
-                </a:tc>
-                <a:tc>
-                  <a:txBody>
-                    <a:bodyPr/>
-                    <a:lstStyle/>
-                    <a:p>
-                      <a:pPr algn="r"/>
-                      <a:r>
-                        <a:rPr sz="1500" b="0">
-                          <a:solidFill>
-                            <a:srgbClr val="4A5A6A"/>
-                          </a:solidFill>
-                          <a:latin typeface="Nimbus Sans"/>
-                          <a:ea typeface="Nimbus Sans"/>
-                          <a:cs typeface="Nimbus Sans"/>
-                        </a:rPr>
-                        <a:t>$10,057,790.62</a:t>
-                      </a:r>
-                    </a:p>
-                  </a:txBody>
-                  <a:tcPr marL="109728" marR="109728" marT="27432" marB="27432" anchor="ctr">
-                    <a:lnL w="0">
-                      <a:noFill/>
-                    </a:lnL>
-                    <a:lnR w="0">
-                      <a:noFill/>
-                    </a:lnR>
-                    <a:lnT w="0">
-                      <a:noFill/>
-                    </a:lnT>
-                    <a:lnB w="9525">
-                      <a:solidFill>
-                        <a:srgbClr val="D5DEE7"/>
-                      </a:solidFill>
-                    </a:lnB>
-                    <a:noFill/>
-                  </a:tcPr>
-                </a:tc>
-                <a:tc>
-                  <a:txBody>
-                    <a:bodyPr/>
-                    <a:lstStyle/>
-                    <a:p>
-                      <a:pPr algn="r"/>
-                      <a:r>
-                        <a:rPr sz="1500" b="0">
-                          <a:solidFill>
-                            <a:srgbClr val="4A5A6A"/>
-                          </a:solidFill>
-                          <a:latin typeface="Nimbus Sans"/>
-                          <a:ea typeface="Nimbus Sans"/>
-                          <a:cs typeface="Nimbus Sans"/>
-                        </a:rPr>
-                        <a:t>$3,792,046.74</a:t>
-                      </a:r>
-                    </a:p>
-                  </a:txBody>
-                  <a:tcPr marL="109728" marR="109728" marT="27432" marB="27432" anchor="ctr">
-                    <a:lnL w="0">
-                      <a:noFill/>
-                    </a:lnL>
-                    <a:lnR w="0">
-                      <a:noFill/>
-                    </a:lnR>
-                    <a:lnT w="0">
-                      <a:noFill/>
-                    </a:lnT>
-                    <a:lnB w="9525">
-                      <a:solidFill>
-                        <a:srgbClr val="D5DEE7"/>
-                      </a:solidFill>
-                    </a:lnB>
-                    <a:noFill/>
-                  </a:tcPr>
-                </a:tc>
-              </a:tr>
-              <a:tr h="338328">
-                <a:tc vMerge="1">
-                  <a:txBody>
-                    <a:bodyPr/>
-                    <a:lstStyle/>
-                    <a:p/>
-                  </a:txBody>
-                  <a:tcPr/>
-                </a:tc>
-                <a:tc>
-                  <a:txBody>
-                    <a:bodyPr/>
-                    <a:lstStyle/>
-                    <a:p>
-                      <a:pPr algn="l"/>
-                      <a:r>
-                        <a:rPr sz="1600" b="1">
-                          <a:solidFill>
-                            <a:srgbClr val="12304D"/>
-                          </a:solidFill>
-                          <a:latin typeface="Nimbus Sans"/>
-                          <a:ea typeface="Nimbus Sans"/>
-                          <a:cs typeface="Nimbus Sans"/>
-                        </a:rPr>
-                        <a:t>Cumplimiento de desembolsos</a:t>
-                      </a:r>
-                    </a:p>
-                  </a:txBody>
-                  <a:tcPr marL="109728" marR="109728" marT="27432" marB="27432" anchor="ctr">
-                    <a:lnL w="0">
-                      <a:noFill/>
-                    </a:lnL>
-                    <a:lnR w="0">
-                      <a:noFill/>
-                    </a:lnR>
-                    <a:lnT w="0">
-                      <a:noFill/>
-                    </a:lnT>
-                    <a:lnB w="9525">
-                      <a:solidFill>
-                        <a:srgbClr val="D5DEE7"/>
-                      </a:solidFill>
-                    </a:lnB>
-                    <a:solidFill>
-                      <a:srgbClr val="EAF2F8"/>
-                    </a:solidFill>
-                  </a:tcPr>
-                </a:tc>
-                <a:tc>
-                  <a:txBody>
-                    <a:bodyPr/>
-                    <a:lstStyle/>
-                    <a:p>
-                      <a:pPr algn="r"/>
-                      <a:r>
-                        <a:rPr sz="1600" b="1">
-                          <a:solidFill>
-                            <a:srgbClr val="1F6B4A"/>
-                          </a:solidFill>
-                          <a:latin typeface="Nimbus Sans"/>
-                          <a:ea typeface="Nimbus Sans"/>
-                          <a:cs typeface="Nimbus Sans"/>
-                        </a:rPr>
-                        <a:t>124.17%</a:t>
-                      </a:r>
-                    </a:p>
-                  </a:txBody>
-                  <a:tcPr marL="109728" marR="109728" marT="27432" marB="27432" anchor="ctr">
-                    <a:lnL w="0">
-                      <a:noFill/>
-                    </a:lnL>
-                    <a:lnR w="0">
-                      <a:noFill/>
-                    </a:lnR>
-                    <a:lnT w="0">
-                      <a:noFill/>
-                    </a:lnT>
-                    <a:lnB w="9525">
-                      <a:solidFill>
-                        <a:srgbClr val="D5DEE7"/>
-                      </a:solidFill>
-                    </a:lnB>
-                    <a:solidFill>
-                      <a:srgbClr val="EAF2F8"/>
-                    </a:solidFill>
-                  </a:tcPr>
-                </a:tc>
-                <a:tc>
-                  <a:txBody>
-                    <a:bodyPr/>
-                    <a:lstStyle/>
-                    <a:p>
-                      <a:pPr algn="r"/>
-                      <a:r>
-                        <a:rPr sz="1600" b="1">
-                          <a:solidFill>
-                            <a:srgbClr val="B83B48"/>
-                          </a:solidFill>
-                          <a:latin typeface="Nimbus Sans"/>
-                          <a:ea typeface="Nimbus Sans"/>
-                          <a:cs typeface="Nimbus Sans"/>
-                        </a:rPr>
-                        <a:t>67.41%</a:t>
-                      </a:r>
-                    </a:p>
-                  </a:txBody>
-                  <a:tcPr marL="109728" marR="109728" marT="27432" marB="27432" anchor="ctr">
-                    <a:lnL w="0">
-                      <a:noFill/>
-                    </a:lnL>
-                    <a:lnR w="0">
-                      <a:noFill/>
-                    </a:lnR>
-                    <a:lnT w="0">
-                      <a:noFill/>
-                    </a:lnT>
-                    <a:lnB w="9525">
-                      <a:solidFill>
-                        <a:srgbClr val="D5DEE7"/>
-                      </a:solidFill>
-                    </a:lnB>
-                    <a:solidFill>
-                      <a:srgbClr val="EAF2F8"/>
-                    </a:solidFill>
-                  </a:tcPr>
-                </a:tc>
-              </a:tr>
-              <a:tr h="128016">
-                <a:tc>
-                  <a:txBody>
-                    <a:bodyPr/>
-                    <a:lstStyle/>
-                    <a:p>
-                      <a:pPr algn="l"/>
-                      <a:r>
-                        <a:rPr sz="400" b="0">
-                          <a:solidFill>
-                            <a:srgbClr val="12304D"/>
-                          </a:solidFill>
-                          <a:latin typeface="Nimbus Sans"/>
-                          <a:ea typeface="Nimbus Sans"/>
-                          <a:cs typeface="Nimbus Sans"/>
-                        </a:rPr>
-                        <a:t/>
-                      </a:r>
-                    </a:p>
-                  </a:txBody>
-                  <a:tcPr marL="109728" marR="109728" marT="0" marB="0" anchor="ctr">
-                    <a:lnL w="0">
-                      <a:noFill/>
-                    </a:lnL>
-                    <a:lnR w="0">
-                      <a:noFill/>
-                    </a:lnR>
-                    <a:lnT w="0">
-                      <a:noFill/>
-                    </a:lnT>
-                    <a:lnB w="0">
-                      <a:noFill/>
-                    </a:lnB>
-                    <a:noFill/>
-                  </a:tcPr>
-                </a:tc>
-                <a:tc>
-                  <a:txBody>
-                    <a:bodyPr/>
-                    <a:lstStyle/>
-                    <a:p>
-                      <a:pPr algn="l"/>
-                      <a:r>
-                        <a:rPr sz="400" b="0">
-                          <a:solidFill>
-                            <a:srgbClr val="12304D"/>
-                          </a:solidFill>
-                          <a:latin typeface="Nimbus Sans"/>
-                          <a:ea typeface="Nimbus Sans"/>
-                          <a:cs typeface="Nimbus Sans"/>
-                        </a:rPr>
-                        <a:t/>
-                      </a:r>
-                    </a:p>
-                  </a:txBody>
-                  <a:tcPr marL="109728" marR="109728" marT="0" marB="0" anchor="ctr">
-                    <a:lnL w="0">
-                      <a:noFill/>
-                    </a:lnL>
-                    <a:lnR w="0">
-                      <a:noFill/>
-                    </a:lnR>
-                    <a:lnT w="0">
-                      <a:noFill/>
-                    </a:lnT>
-                    <a:lnB w="0">
-                      <a:noFill/>
-                    </a:lnB>
-                    <a:noFill/>
-                  </a:tcPr>
-                </a:tc>
-                <a:tc>
-                  <a:txBody>
-                    <a:bodyPr/>
-                    <a:lstStyle/>
-                    <a:p>
-                      <a:pPr algn="l"/>
-                      <a:r>
-                        <a:rPr sz="400" b="0">
-                          <a:solidFill>
-                            <a:srgbClr val="12304D"/>
-                          </a:solidFill>
-                          <a:latin typeface="Nimbus Sans"/>
-                          <a:ea typeface="Nimbus Sans"/>
-                          <a:cs typeface="Nimbus Sans"/>
-                        </a:rPr>
-                        <a:t/>
-                      </a:r>
-                    </a:p>
-                  </a:txBody>
-                  <a:tcPr marL="109728" marR="109728" marT="0" marB="0" anchor="ctr">
-                    <a:lnL w="0">
-                      <a:noFill/>
-                    </a:lnL>
-                    <a:lnR w="0">
-                      <a:noFill/>
-                    </a:lnR>
-                    <a:lnT w="0">
-                      <a:noFill/>
-                    </a:lnT>
-                    <a:lnB w="0">
-                      <a:noFill/>
-                    </a:lnB>
-                    <a:noFill/>
-                  </a:tcPr>
-                </a:tc>
-                <a:tc>
-                  <a:txBody>
-                    <a:bodyPr/>
-                    <a:lstStyle/>
-                    <a:p>
-                      <a:pPr algn="l"/>
-                      <a:r>
-                        <a:rPr sz="400" b="0">
-                          <a:solidFill>
-                            <a:srgbClr val="12304D"/>
-                          </a:solidFill>
-                          <a:latin typeface="Nimbus Sans"/>
-                          <a:ea typeface="Nimbus Sans"/>
-                          <a:cs typeface="Nimbus Sans"/>
-                        </a:rPr>
-                        <a:t/>
-                      </a:r>
-                    </a:p>
-                  </a:txBody>
-                  <a:tcPr marL="109728" marR="109728" marT="0" marB="0" anchor="ctr">
-                    <a:lnL w="0">
-                      <a:noFill/>
-                    </a:lnL>
-                    <a:lnR w="0">
-                      <a:noFill/>
-                    </a:lnR>
-                    <a:lnT w="0">
-                      <a:noFill/>
-                    </a:lnT>
-                    <a:lnB w="0">
-                      <a:noFill/>
-                    </a:lnB>
-                    <a:noFill/>
-                  </a:tcPr>
-                </a:tc>
-              </a:tr>
-              <a:tr h="338328">
-                <a:tc rowSpan="3">
-                  <a:txBody>
-                    <a:bodyPr wrap="square"/>
-                    <a:lstStyle/>
-                    <a:p>
-                      <a:pPr algn="l"/>
-                      <a:r>
-                        <a:rPr sz="1500" b="1">
-                          <a:solidFill>
-                            <a:srgbClr val="12304D"/>
-                          </a:solidFill>
-                          <a:latin typeface="Nimbus Sans"/>
-                          <a:ea typeface="Nimbus Sans"/>
-                          <a:cs typeface="Nimbus Sans"/>
-                        </a:rPr>
-                        <a:t>2. Colocación neta</a:t>
-                      </a:r>
-                    </a:p>
-                  </a:txBody>
-                  <a:tcPr marL="109728" marR="109728" marT="27432" marB="27432" anchor="ctr">
-                    <a:lnL w="0">
-                      <a:noFill/>
-                    </a:lnL>
-                    <a:lnR w="0">
-                      <a:noFill/>
-                    </a:lnR>
-                    <a:lnT w="0">
-                      <a:noFill/>
-                    </a:lnT>
-                    <a:lnB w="0">
-                      <a:noFill/>
-                    </a:lnB>
-                    <a:solidFill>
-                      <a:srgbClr val="F3F6F9"/>
-                    </a:solidFill>
-                  </a:tcPr>
-                </a:tc>
-                <a:tc>
-                  <a:txBody>
-                    <a:bodyPr/>
-                    <a:lstStyle/>
-                    <a:p>
-                      <a:pPr algn="l"/>
-                      <a:r>
-                        <a:rPr sz="1500" b="0">
-                          <a:solidFill>
-                            <a:srgbClr val="4A5A6A"/>
-                          </a:solidFill>
-                          <a:latin typeface="Nimbus Sans"/>
-                          <a:ea typeface="Nimbus Sans"/>
-                          <a:cs typeface="Nimbus Sans"/>
-                        </a:rPr>
-                        <a:t>Amortización natural (−)</a:t>
-                      </a:r>
-                    </a:p>
-                  </a:txBody>
-                  <a:tcPr marL="109728" marR="109728" marT="27432" marB="27432" anchor="ctr">
-                    <a:lnL w="0">
-                      <a:noFill/>
-                    </a:lnL>
-                    <a:lnR w="0">
-                      <a:noFill/>
-                    </a:lnR>
-                    <a:lnT w="0">
-                      <a:noFill/>
-                    </a:lnT>
-                    <a:lnB w="9525">
-                      <a:solidFill>
-                        <a:srgbClr val="D5DEE7"/>
-                      </a:solidFill>
-                    </a:lnB>
-                    <a:noFill/>
-                  </a:tcPr>
-                </a:tc>
-                <a:tc>
-                  <a:txBody>
-                    <a:bodyPr/>
-                    <a:lstStyle/>
-                    <a:p>
-                      <a:pPr algn="r"/>
-                      <a:r>
-                        <a:rPr sz="1500" b="0">
-                          <a:solidFill>
-                            <a:srgbClr val="4A5A6A"/>
-                          </a:solidFill>
-                          <a:latin typeface="Nimbus Sans"/>
-                          <a:ea typeface="Nimbus Sans"/>
-                          <a:cs typeface="Nimbus Sans"/>
-                        </a:rPr>
-                        <a:t>$4,704,882.17</a:t>
-                      </a:r>
-                    </a:p>
-                  </a:txBody>
-                  <a:tcPr marL="109728" marR="109728" marT="27432" marB="27432" anchor="ctr">
-                    <a:lnL w="0">
-                      <a:noFill/>
-                    </a:lnL>
-                    <a:lnR w="0">
-                      <a:noFill/>
-                    </a:lnR>
-                    <a:lnT w="0">
-                      <a:noFill/>
-                    </a:lnT>
-                    <a:lnB w="9525">
-                      <a:solidFill>
-                        <a:srgbClr val="D5DEE7"/>
-                      </a:solidFill>
-                    </a:lnB>
-                    <a:noFill/>
-                  </a:tcPr>
-                </a:tc>
-                <a:tc>
-                  <a:txBody>
-                    <a:bodyPr/>
-                    <a:lstStyle/>
-                    <a:p>
-                      <a:pPr algn="r"/>
-                      <a:r>
-                        <a:rPr sz="1500" b="0">
-                          <a:solidFill>
-                            <a:srgbClr val="4A5A6A"/>
-                          </a:solidFill>
-                          <a:latin typeface="Nimbus Sans"/>
-                          <a:ea typeface="Nimbus Sans"/>
-                          <a:cs typeface="Nimbus Sans"/>
-                        </a:rPr>
-                        <a:t>$2,587,564.25</a:t>
-                      </a:r>
-                    </a:p>
-                  </a:txBody>
-                  <a:tcPr marL="109728" marR="109728" marT="27432" marB="27432" anchor="ctr">
-                    <a:lnL w="0">
-                      <a:noFill/>
-                    </a:lnL>
-                    <a:lnR w="0">
-                      <a:noFill/>
-                    </a:lnR>
-                    <a:lnT w="0">
-                      <a:noFill/>
-                    </a:lnT>
-                    <a:lnB w="9525">
-                      <a:solidFill>
-                        <a:srgbClr val="D5DEE7"/>
-                      </a:solidFill>
-                    </a:lnB>
-                    <a:noFill/>
-                  </a:tcPr>
-                </a:tc>
-              </a:tr>
-              <a:tr h="338328">
-                <a:tc vMerge="1">
-                  <a:txBody>
-                    <a:bodyPr/>
-                    <a:lstStyle/>
-                    <a:p/>
-                  </a:txBody>
-                  <a:tcPr/>
-                </a:tc>
-                <a:tc>
-                  <a:txBody>
-                    <a:bodyPr/>
-                    <a:lstStyle/>
-                    <a:p>
-                      <a:pPr algn="l"/>
-                      <a:r>
-                        <a:rPr sz="1500" b="0">
-                          <a:solidFill>
-                            <a:srgbClr val="4A5A6A"/>
-                          </a:solidFill>
-                          <a:latin typeface="Nimbus Sans"/>
-                          <a:ea typeface="Nimbus Sans"/>
-                          <a:cs typeface="Nimbus Sans"/>
-                        </a:rPr>
-                        <a:t>Cancelaciones anticipadas (−)</a:t>
-                      </a:r>
-                    </a:p>
-                  </a:txBody>
-                  <a:tcPr marL="109728" marR="109728" marT="27432" marB="27432" anchor="ctr">
-                    <a:lnL w="0">
-                      <a:noFill/>
-                    </a:lnL>
-                    <a:lnR w="0">
-                      <a:noFill/>
-                    </a:lnR>
-                    <a:lnT w="0">
-                      <a:noFill/>
-                    </a:lnT>
-                    <a:lnB w="9525">
-                      <a:solidFill>
-                        <a:srgbClr val="D5DEE7"/>
-                      </a:solidFill>
-                    </a:lnB>
-                    <a:noFill/>
-                  </a:tcPr>
-                </a:tc>
-                <a:tc>
-                  <a:txBody>
-                    <a:bodyPr/>
-                    <a:lstStyle/>
-                    <a:p>
-                      <a:pPr algn="r"/>
-                      <a:r>
-                        <a:rPr sz="1500" b="0">
-                          <a:solidFill>
-                            <a:srgbClr val="4A5A6A"/>
-                          </a:solidFill>
-                          <a:latin typeface="Nimbus Sans"/>
-                          <a:ea typeface="Nimbus Sans"/>
-                          <a:cs typeface="Nimbus Sans"/>
-                        </a:rPr>
-                        <a:t>$4,467,774.82</a:t>
-                      </a:r>
-                    </a:p>
-                  </a:txBody>
-                  <a:tcPr marL="109728" marR="109728" marT="27432" marB="27432" anchor="ctr">
-                    <a:lnL w="0">
-                      <a:noFill/>
-                    </a:lnL>
-                    <a:lnR w="0">
-                      <a:noFill/>
-                    </a:lnR>
-                    <a:lnT w="0">
-                      <a:noFill/>
-                    </a:lnT>
-                    <a:lnB w="9525">
-                      <a:solidFill>
-                        <a:srgbClr val="D5DEE7"/>
-                      </a:solidFill>
-                    </a:lnB>
-                    <a:noFill/>
-                  </a:tcPr>
-                </a:tc>
-                <a:tc>
-                  <a:txBody>
-                    <a:bodyPr/>
-                    <a:lstStyle/>
-                    <a:p>
-                      <a:pPr algn="r"/>
-                      <a:r>
-                        <a:rPr sz="1500" b="0">
-                          <a:solidFill>
-                            <a:srgbClr val="4A5A6A"/>
-                          </a:solidFill>
-                          <a:latin typeface="Nimbus Sans"/>
-                          <a:ea typeface="Nimbus Sans"/>
-                          <a:cs typeface="Nimbus Sans"/>
-                        </a:rPr>
-                        <a:t>$441,076.94</a:t>
-                      </a:r>
-                    </a:p>
-                  </a:txBody>
-                  <a:tcPr marL="109728" marR="109728" marT="27432" marB="27432" anchor="ctr">
-                    <a:lnL w="0">
-                      <a:noFill/>
-                    </a:lnL>
-                    <a:lnR w="0">
-                      <a:noFill/>
-                    </a:lnR>
-                    <a:lnT w="0">
-                      <a:noFill/>
-                    </a:lnT>
-                    <a:lnB w="9525">
-                      <a:solidFill>
-                        <a:srgbClr val="D5DEE7"/>
-                      </a:solidFill>
-                    </a:lnB>
-                    <a:noFill/>
-                  </a:tcPr>
-                </a:tc>
-              </a:tr>
-              <a:tr h="338328">
-                <a:tc vMerge="1">
-                  <a:txBody>
-                    <a:bodyPr/>
-                    <a:lstStyle/>
-                    <a:p/>
-                  </a:txBody>
-                  <a:tcPr/>
-                </a:tc>
-                <a:tc>
-                  <a:txBody>
-                    <a:bodyPr/>
-                    <a:lstStyle/>
-                    <a:p>
-                      <a:pPr algn="l"/>
-                      <a:r>
-                        <a:rPr sz="1600" b="1">
-                          <a:solidFill>
-                            <a:srgbClr val="12304D"/>
-                          </a:solidFill>
-                          <a:latin typeface="Nimbus Sans"/>
-                          <a:ea typeface="Nimbus Sans"/>
-                          <a:cs typeface="Nimbus Sans"/>
-                        </a:rPr>
-                        <a:t>Colocación Neta de desembolsos</a:t>
-                      </a:r>
-                    </a:p>
-                  </a:txBody>
-                  <a:tcPr marL="109728" marR="109728" marT="27432" marB="27432" anchor="ctr">
-                    <a:lnL w="0">
-                      <a:noFill/>
-                    </a:lnL>
-                    <a:lnR w="0">
-                      <a:noFill/>
-                    </a:lnR>
-                    <a:lnT w="0">
-                      <a:noFill/>
-                    </a:lnT>
-                    <a:lnB w="9525">
-                      <a:solidFill>
-                        <a:srgbClr val="D5DEE7"/>
-                      </a:solidFill>
-                    </a:lnB>
-                    <a:solidFill>
-                      <a:srgbClr val="EAF2F8"/>
-                    </a:solidFill>
-                  </a:tcPr>
-                </a:tc>
-                <a:tc>
-                  <a:txBody>
-                    <a:bodyPr/>
-                    <a:lstStyle/>
-                    <a:p>
-                      <a:pPr algn="r"/>
-                      <a:r>
-                        <a:rPr sz="1600" b="1">
-                          <a:solidFill>
-                            <a:srgbClr val="1F6B4A"/>
-                          </a:solidFill>
-                          <a:latin typeface="Nimbus Sans"/>
-                          <a:ea typeface="Nimbus Sans"/>
-                          <a:cs typeface="Nimbus Sans"/>
-                        </a:rPr>
-                        <a:t>$885,133.63</a:t>
-                      </a:r>
-                    </a:p>
-                  </a:txBody>
-                  <a:tcPr marL="109728" marR="109728" marT="27432" marB="27432" anchor="ctr">
-                    <a:lnL w="0">
-                      <a:noFill/>
-                    </a:lnL>
-                    <a:lnR w="0">
-                      <a:noFill/>
-                    </a:lnR>
-                    <a:lnT w="0">
-                      <a:noFill/>
-                    </a:lnT>
-                    <a:lnB w="9525">
-                      <a:solidFill>
-                        <a:srgbClr val="D5DEE7"/>
-                      </a:solidFill>
-                    </a:lnB>
-                    <a:solidFill>
-                      <a:srgbClr val="EAF2F8"/>
-                    </a:solidFill>
-                  </a:tcPr>
-                </a:tc>
-                <a:tc>
-                  <a:txBody>
-                    <a:bodyPr/>
-                    <a:lstStyle/>
-                    <a:p>
-                      <a:pPr algn="r"/>
-                      <a:r>
-                        <a:rPr sz="1600" b="1">
-                          <a:solidFill>
-                            <a:srgbClr val="1F6B4A"/>
-                          </a:solidFill>
-                          <a:latin typeface="Nimbus Sans"/>
-                          <a:ea typeface="Nimbus Sans"/>
-                          <a:cs typeface="Nimbus Sans"/>
-                        </a:rPr>
-                        <a:t>$763,405.55</a:t>
-                      </a:r>
-                    </a:p>
-                  </a:txBody>
-                  <a:tcPr marL="109728" marR="109728" marT="27432" marB="27432" anchor="ctr">
-                    <a:lnL w="0">
-                      <a:noFill/>
-                    </a:lnL>
-                    <a:lnR w="0">
-                      <a:noFill/>
-                    </a:lnR>
-                    <a:lnT w="0">
-                      <a:noFill/>
-                    </a:lnT>
-                    <a:lnB w="9525">
-                      <a:solidFill>
-                        <a:srgbClr val="D5DEE7"/>
-                      </a:solidFill>
-                    </a:lnB>
-                    <a:solidFill>
-                      <a:srgbClr val="EAF2F8"/>
-                    </a:solidFill>
-                  </a:tcPr>
-                </a:tc>
-              </a:tr>
-              <a:tr h="128016">
-                <a:tc>
-                  <a:txBody>
-                    <a:bodyPr/>
-                    <a:lstStyle/>
-                    <a:p>
-                      <a:pPr algn="l"/>
-                      <a:r>
-                        <a:rPr sz="400" b="0">
-                          <a:solidFill>
-                            <a:srgbClr val="12304D"/>
-                          </a:solidFill>
-                          <a:latin typeface="Nimbus Sans"/>
-                          <a:ea typeface="Nimbus Sans"/>
-                          <a:cs typeface="Nimbus Sans"/>
-                        </a:rPr>
-                        <a:t/>
-                      </a:r>
-                    </a:p>
-                  </a:txBody>
-                  <a:tcPr marL="109728" marR="109728" marT="0" marB="0" anchor="ctr">
-                    <a:lnL w="0">
-                      <a:noFill/>
-                    </a:lnL>
-                    <a:lnR w="0">
-                      <a:noFill/>
-                    </a:lnR>
-                    <a:lnT w="0">
-                      <a:noFill/>
-                    </a:lnT>
-                    <a:lnB w="0">
-                      <a:noFill/>
-                    </a:lnB>
-                    <a:noFill/>
-                  </a:tcPr>
-                </a:tc>
-                <a:tc>
-                  <a:txBody>
-                    <a:bodyPr/>
-                    <a:lstStyle/>
-                    <a:p>
-                      <a:pPr algn="l"/>
-                      <a:r>
-                        <a:rPr sz="400" b="0">
-                          <a:solidFill>
-                            <a:srgbClr val="12304D"/>
-                          </a:solidFill>
-                          <a:latin typeface="Nimbus Sans"/>
-                          <a:ea typeface="Nimbus Sans"/>
-                          <a:cs typeface="Nimbus Sans"/>
-                        </a:rPr>
-                        <a:t/>
-                      </a:r>
-                    </a:p>
-                  </a:txBody>
-                  <a:tcPr marL="109728" marR="109728" marT="0" marB="0" anchor="ctr">
-                    <a:lnL w="0">
-                      <a:noFill/>
-                    </a:lnL>
-                    <a:lnR w="0">
-                      <a:noFill/>
-                    </a:lnR>
-                    <a:lnT w="0">
-                      <a:noFill/>
-                    </a:lnT>
-                    <a:lnB w="0">
-                      <a:noFill/>
-                    </a:lnB>
-                    <a:noFill/>
-                  </a:tcPr>
-                </a:tc>
-                <a:tc>
-                  <a:txBody>
-                    <a:bodyPr/>
-                    <a:lstStyle/>
-                    <a:p>
-                      <a:pPr algn="l"/>
-                      <a:r>
-                        <a:rPr sz="400" b="0">
-                          <a:solidFill>
-                            <a:srgbClr val="12304D"/>
-                          </a:solidFill>
-                          <a:latin typeface="Nimbus Sans"/>
-                          <a:ea typeface="Nimbus Sans"/>
-                          <a:cs typeface="Nimbus Sans"/>
-                        </a:rPr>
-                        <a:t/>
-                      </a:r>
-                    </a:p>
-                  </a:txBody>
-                  <a:tcPr marL="109728" marR="109728" marT="0" marB="0" anchor="ctr">
-                    <a:lnL w="0">
-                      <a:noFill/>
-                    </a:lnL>
-                    <a:lnR w="0">
-                      <a:noFill/>
-                    </a:lnR>
-                    <a:lnT w="0">
-                      <a:noFill/>
-                    </a:lnT>
-                    <a:lnB w="0">
-                      <a:noFill/>
-                    </a:lnB>
-                    <a:noFill/>
-                  </a:tcPr>
-                </a:tc>
-                <a:tc>
-                  <a:txBody>
-                    <a:bodyPr/>
-                    <a:lstStyle/>
-                    <a:p>
-                      <a:pPr algn="l"/>
-                      <a:r>
-                        <a:rPr sz="400" b="0">
-                          <a:solidFill>
-                            <a:srgbClr val="12304D"/>
-                          </a:solidFill>
-                          <a:latin typeface="Nimbus Sans"/>
-                          <a:ea typeface="Nimbus Sans"/>
-                          <a:cs typeface="Nimbus Sans"/>
-                        </a:rPr>
-                        <a:t/>
-                      </a:r>
-                    </a:p>
-                  </a:txBody>
-                  <a:tcPr marL="109728" marR="109728" marT="0" marB="0" anchor="ctr">
-                    <a:lnL w="0">
-                      <a:noFill/>
-                    </a:lnL>
-                    <a:lnR w="0">
-                      <a:noFill/>
-                    </a:lnR>
-                    <a:lnT w="0">
-                      <a:noFill/>
-                    </a:lnT>
-                    <a:lnB w="0">
-                      <a:noFill/>
-                    </a:lnB>
-                    <a:noFill/>
-                  </a:tcPr>
-                </a:tc>
-              </a:tr>
-              <a:tr h="338328">
-                <a:tc rowSpan="5">
-                  <a:txBody>
-                    <a:bodyPr wrap="square"/>
-                    <a:lstStyle/>
-                    <a:p>
-                      <a:pPr algn="l"/>
-                      <a:r>
-                        <a:rPr sz="1500" b="1">
-                          <a:solidFill>
-                            <a:srgbClr val="12304D"/>
-                          </a:solidFill>
-                          <a:latin typeface="Nimbus Sans"/>
-                          <a:ea typeface="Nimbus Sans"/>
-                          <a:cs typeface="Nimbus Sans"/>
-                        </a:rPr>
-                        <a:t>3. Crecimiento de cartera</a:t>
-                      </a:r>
-                    </a:p>
-                  </a:txBody>
-                  <a:tcPr marL="109728" marR="109728" marT="27432" marB="27432" anchor="ctr">
-                    <a:lnL w="0">
-                      <a:noFill/>
-                    </a:lnL>
-                    <a:lnR w="0">
-                      <a:noFill/>
-                    </a:lnR>
-                    <a:lnT w="0">
-                      <a:noFill/>
-                    </a:lnT>
-                    <a:lnB w="0">
-                      <a:noFill/>
-                    </a:lnB>
-                    <a:solidFill>
-                      <a:srgbClr val="F3F6F9"/>
-                    </a:solidFill>
-                  </a:tcPr>
-                </a:tc>
-                <a:tc>
-                  <a:txBody>
-                    <a:bodyPr/>
-                    <a:lstStyle/>
-                    <a:p>
-                      <a:pPr algn="l"/>
-                      <a:r>
-                        <a:rPr sz="1500" b="0">
-                          <a:solidFill>
-                            <a:srgbClr val="4A5A6A"/>
-                          </a:solidFill>
-                          <a:latin typeface="Nimbus Sans"/>
-                          <a:ea typeface="Nimbus Sans"/>
-                          <a:cs typeface="Nimbus Sans"/>
-                        </a:rPr>
-                        <a:t>Saldo de cartera al cierre de septiembre</a:t>
-                      </a:r>
-                    </a:p>
-                  </a:txBody>
-                  <a:tcPr marL="109728" marR="109728" marT="27432" marB="27432" anchor="ctr">
-                    <a:lnL w="0">
-                      <a:noFill/>
-                    </a:lnL>
-                    <a:lnR w="0">
-                      <a:noFill/>
-                    </a:lnR>
-                    <a:lnT w="0">
-                      <a:noFill/>
-                    </a:lnT>
-                    <a:lnB w="9525">
-                      <a:solidFill>
-                        <a:srgbClr val="D5DEE7"/>
-                      </a:solidFill>
-                    </a:lnB>
-                    <a:noFill/>
-                  </a:tcPr>
-                </a:tc>
-                <a:tc>
-                  <a:txBody>
-                    <a:bodyPr/>
-                    <a:lstStyle/>
-                    <a:p>
-                      <a:pPr algn="r"/>
-                      <a:r>
-                        <a:rPr sz="1500" b="0">
-                          <a:solidFill>
-                            <a:srgbClr val="4A5A6A"/>
-                          </a:solidFill>
-                          <a:latin typeface="Nimbus Sans"/>
-                          <a:ea typeface="Nimbus Sans"/>
-                          <a:cs typeface="Nimbus Sans"/>
-                        </a:rPr>
-                        <a:t>$80,151,314.67</a:t>
-                      </a:r>
-                    </a:p>
-                  </a:txBody>
-                  <a:tcPr marL="109728" marR="109728" marT="27432" marB="27432" anchor="ctr">
-                    <a:lnL w="0">
-                      <a:noFill/>
-                    </a:lnL>
-                    <a:lnR w="0">
-                      <a:noFill/>
-                    </a:lnR>
-                    <a:lnT w="0">
-                      <a:noFill/>
-                    </a:lnT>
-                    <a:lnB w="9525">
-                      <a:solidFill>
-                        <a:srgbClr val="D5DEE7"/>
-                      </a:solidFill>
-                    </a:lnB>
-                    <a:noFill/>
-                  </a:tcPr>
-                </a:tc>
-                <a:tc>
-                  <a:txBody>
-                    <a:bodyPr/>
-                    <a:lstStyle/>
-                    <a:p>
-                      <a:pPr algn="r"/>
-                      <a:r>
-                        <a:rPr sz="1500" b="0">
-                          <a:solidFill>
-                            <a:srgbClr val="4A5A6A"/>
-                          </a:solidFill>
-                          <a:latin typeface="Nimbus Sans"/>
-                          <a:ea typeface="Nimbus Sans"/>
-                          <a:cs typeface="Nimbus Sans"/>
-                        </a:rPr>
-                        <a:t>$28,279,390.71</a:t>
-                      </a:r>
-                    </a:p>
-                  </a:txBody>
-                  <a:tcPr marL="109728" marR="109728" marT="27432" marB="27432" anchor="ctr">
-                    <a:lnL w="0">
-                      <a:noFill/>
-                    </a:lnL>
-                    <a:lnR w="0">
-                      <a:noFill/>
-                    </a:lnR>
-                    <a:lnT w="0">
-                      <a:noFill/>
-                    </a:lnT>
-                    <a:lnB w="9525">
-                      <a:solidFill>
-                        <a:srgbClr val="D5DEE7"/>
-                      </a:solidFill>
-                    </a:lnB>
-                    <a:noFill/>
-                  </a:tcPr>
-                </a:tc>
-              </a:tr>
-              <a:tr h="338328">
-                <a:tc vMerge="1">
-                  <a:txBody>
-                    <a:bodyPr/>
-                    <a:lstStyle/>
-                    <a:p/>
-                  </a:txBody>
-                  <a:tcPr/>
-                </a:tc>
-                <a:tc>
-                  <a:txBody>
-                    <a:bodyPr/>
-                    <a:lstStyle/>
-                    <a:p>
-                      <a:pPr algn="l"/>
-                      <a:r>
-                        <a:rPr sz="1600" b="1">
-                          <a:solidFill>
-                            <a:srgbClr val="12304D"/>
-                          </a:solidFill>
-                          <a:latin typeface="Nimbus Sans"/>
-                          <a:ea typeface="Nimbus Sans"/>
-                          <a:cs typeface="Nimbus Sans"/>
-                        </a:rPr>
-                        <a:t>Crecimiento de cartera</a:t>
-                      </a:r>
-                    </a:p>
-                  </a:txBody>
-                  <a:tcPr marL="109728" marR="109728" marT="27432" marB="27432" anchor="ctr">
-                    <a:lnL w="0">
-                      <a:noFill/>
-                    </a:lnL>
-                    <a:lnR w="0">
-                      <a:noFill/>
-                    </a:lnR>
-                    <a:lnT w="0">
-                      <a:noFill/>
-                    </a:lnT>
-                    <a:lnB w="9525">
-                      <a:solidFill>
-                        <a:srgbClr val="D5DEE7"/>
-                      </a:solidFill>
-                    </a:lnB>
-                    <a:solidFill>
-                      <a:srgbClr val="FBECEE"/>
-                    </a:solidFill>
-                  </a:tcPr>
-                </a:tc>
-                <a:tc>
-                  <a:txBody>
-                    <a:bodyPr/>
-                    <a:lstStyle/>
-                    <a:p>
-                      <a:pPr algn="r"/>
-                      <a:r>
-                        <a:rPr sz="1600" b="1">
-                          <a:solidFill>
-                            <a:srgbClr val="B83B48"/>
-                          </a:solidFill>
-                          <a:latin typeface="Nimbus Sans"/>
-                          <a:ea typeface="Nimbus Sans"/>
-                          <a:cs typeface="Nimbus Sans"/>
-                        </a:rPr>
-                        <a:t>−$845,243.40</a:t>
-                      </a:r>
-                    </a:p>
-                  </a:txBody>
-                  <a:tcPr marL="109728" marR="109728" marT="27432" marB="27432" anchor="ctr">
-                    <a:lnL w="0">
-                      <a:noFill/>
-                    </a:lnL>
-                    <a:lnR w="0">
-                      <a:noFill/>
-                    </a:lnR>
-                    <a:lnT w="0">
-                      <a:noFill/>
-                    </a:lnT>
-                    <a:lnB w="9525">
-                      <a:solidFill>
-                        <a:srgbClr val="D5DEE7"/>
-                      </a:solidFill>
-                    </a:lnB>
-                    <a:solidFill>
-                      <a:srgbClr val="FBECEE"/>
-                    </a:solidFill>
-                  </a:tcPr>
-                </a:tc>
-                <a:tc>
-                  <a:txBody>
-                    <a:bodyPr/>
-                    <a:lstStyle/>
-                    <a:p>
-                      <a:pPr algn="r"/>
-                      <a:r>
-                        <a:rPr sz="1600" b="1">
-                          <a:solidFill>
-                            <a:srgbClr val="B83B48"/>
-                          </a:solidFill>
-                          <a:latin typeface="Nimbus Sans"/>
-                          <a:ea typeface="Nimbus Sans"/>
-                          <a:cs typeface="Nimbus Sans"/>
-                        </a:rPr>
-                        <a:t>−$84,530.22</a:t>
-                      </a:r>
-                    </a:p>
-                  </a:txBody>
-                  <a:tcPr marL="109728" marR="109728" marT="27432" marB="27432" anchor="ctr">
-                    <a:lnL w="0">
-                      <a:noFill/>
-                    </a:lnL>
-                    <a:lnR w="0">
-                      <a:noFill/>
-                    </a:lnR>
-                    <a:lnT w="0">
-                      <a:noFill/>
-                    </a:lnT>
-                    <a:lnB w="9525">
-                      <a:solidFill>
-                        <a:srgbClr val="D5DEE7"/>
-                      </a:solidFill>
-                    </a:lnB>
-                    <a:solidFill>
-                      <a:srgbClr val="FBECEE"/>
-                    </a:solidFill>
-                  </a:tcPr>
-                </a:tc>
-              </a:tr>
-              <a:tr h="338328">
-                <a:tc vMerge="1">
-                  <a:txBody>
-                    <a:bodyPr/>
-                    <a:lstStyle/>
-                    <a:p/>
-                  </a:txBody>
-                  <a:tcPr/>
-                </a:tc>
-                <a:tc>
-                  <a:txBody>
-                    <a:bodyPr/>
-                    <a:lstStyle/>
-                    <a:p>
-                      <a:pPr algn="l"/>
-                      <a:r>
-                        <a:rPr sz="1500" b="0">
-                          <a:solidFill>
-                            <a:srgbClr val="4A5A6A"/>
-                          </a:solidFill>
-                          <a:latin typeface="Nimbus Sans"/>
-                          <a:ea typeface="Nimbus Sans"/>
-                          <a:cs typeface="Nimbus Sans"/>
-                        </a:rPr>
-                        <a:t>Meta de crecimiento de cartera</a:t>
-                      </a:r>
-                    </a:p>
-                  </a:txBody>
-                  <a:tcPr marL="109728" marR="109728" marT="27432" marB="27432" anchor="ctr">
-                    <a:lnL w="0">
-                      <a:noFill/>
-                    </a:lnL>
-                    <a:lnR w="0">
-                      <a:noFill/>
-                    </a:lnR>
-                    <a:lnT w="0">
-                      <a:noFill/>
-                    </a:lnT>
-                    <a:lnB w="9525">
-                      <a:solidFill>
-                        <a:srgbClr val="D5DEE7"/>
-                      </a:solidFill>
-                    </a:lnB>
-                    <a:noFill/>
-                  </a:tcPr>
-                </a:tc>
-                <a:tc>
-                  <a:txBody>
-                    <a:bodyPr/>
-                    <a:lstStyle/>
-                    <a:p>
-                      <a:pPr algn="r"/>
-                      <a:r>
-                        <a:rPr sz="1500" b="0">
-                          <a:solidFill>
-                            <a:srgbClr val="4A5A6A"/>
-                          </a:solidFill>
-                          <a:latin typeface="Nimbus Sans"/>
-                          <a:ea typeface="Nimbus Sans"/>
-                          <a:cs typeface="Nimbus Sans"/>
-                        </a:rPr>
-                        <a:t>$2,393,084.78</a:t>
-                      </a:r>
-                    </a:p>
-                  </a:txBody>
-                  <a:tcPr marL="109728" marR="109728" marT="27432" marB="27432" anchor="ctr">
-                    <a:lnL w="0">
-                      <a:noFill/>
-                    </a:lnL>
-                    <a:lnR w="0">
-                      <a:noFill/>
-                    </a:lnR>
-                    <a:lnT w="0">
-                      <a:noFill/>
-                    </a:lnT>
-                    <a:lnB w="9525">
-                      <a:solidFill>
-                        <a:srgbClr val="D5DEE7"/>
-                      </a:solidFill>
-                    </a:lnB>
-                    <a:noFill/>
-                  </a:tcPr>
-                </a:tc>
-                <a:tc>
-                  <a:txBody>
-                    <a:bodyPr/>
-                    <a:lstStyle/>
-                    <a:p>
-                      <a:pPr algn="r"/>
-                      <a:r>
-                        <a:rPr sz="1500" b="0">
-                          <a:solidFill>
-                            <a:srgbClr val="4A5A6A"/>
-                          </a:solidFill>
-                          <a:latin typeface="Nimbus Sans"/>
-                          <a:ea typeface="Nimbus Sans"/>
-                          <a:cs typeface="Nimbus Sans"/>
-                        </a:rPr>
-                        <a:t>$867,493.23</a:t>
-                      </a:r>
-                    </a:p>
-                  </a:txBody>
-                  <a:tcPr marL="109728" marR="109728" marT="27432" marB="27432" anchor="ctr">
-                    <a:lnL w="0">
-                      <a:noFill/>
-                    </a:lnL>
-                    <a:lnR w="0">
-                      <a:noFill/>
-                    </a:lnR>
-                    <a:lnT w="0">
-                      <a:noFill/>
-                    </a:lnT>
-                    <a:lnB w="9525">
-                      <a:solidFill>
-                        <a:srgbClr val="D5DEE7"/>
-                      </a:solidFill>
-                    </a:lnB>
-                    <a:noFill/>
-                  </a:tcPr>
-                </a:tc>
-              </a:tr>
-              <a:tr h="338328">
-                <a:tc vMerge="1">
-                  <a:txBody>
-                    <a:bodyPr/>
-                    <a:lstStyle/>
-                    <a:p/>
-                  </a:txBody>
-                  <a:tcPr/>
-                </a:tc>
-                <a:tc>
-                  <a:txBody>
-                    <a:bodyPr/>
-                    <a:lstStyle/>
-                    <a:p>
-                      <a:pPr algn="l"/>
-                      <a:r>
-                        <a:rPr sz="1600" b="1">
-                          <a:solidFill>
-                            <a:srgbClr val="12304D"/>
-                          </a:solidFill>
-                          <a:latin typeface="Nimbus Sans"/>
-                          <a:ea typeface="Nimbus Sans"/>
-                          <a:cs typeface="Nimbus Sans"/>
-                        </a:rPr>
-                        <a:t>Cumplimiento de la meta de crecimiento</a:t>
-                      </a:r>
-                    </a:p>
-                  </a:txBody>
-                  <a:tcPr marL="109728" marR="109728" marT="27432" marB="27432" anchor="ctr">
-                    <a:lnL w="0">
-                      <a:noFill/>
-                    </a:lnL>
-                    <a:lnR w="0">
-                      <a:noFill/>
-                    </a:lnR>
-                    <a:lnT w="0">
-                      <a:noFill/>
-                    </a:lnT>
-                    <a:lnB w="9525">
-                      <a:solidFill>
-                        <a:srgbClr val="D5DEE7"/>
-                      </a:solidFill>
-                    </a:lnB>
-                    <a:solidFill>
-                      <a:srgbClr val="FBECEE"/>
-                    </a:solidFill>
-                  </a:tcPr>
-                </a:tc>
-                <a:tc>
-                  <a:txBody>
-                    <a:bodyPr/>
-                    <a:lstStyle/>
-                    <a:p>
-                      <a:pPr algn="r"/>
-                      <a:r>
-                        <a:rPr sz="1600" b="1">
-                          <a:solidFill>
-                            <a:srgbClr val="B83B48"/>
-                          </a:solidFill>
-                          <a:latin typeface="Nimbus Sans"/>
-                          <a:ea typeface="Nimbus Sans"/>
-                          <a:cs typeface="Nimbus Sans"/>
-                        </a:rPr>
-                        <a:t>-35.32%</a:t>
-                      </a:r>
-                    </a:p>
-                  </a:txBody>
-                  <a:tcPr marL="109728" marR="109728" marT="27432" marB="27432" anchor="ctr">
-                    <a:lnL w="0">
-                      <a:noFill/>
-                    </a:lnL>
-                    <a:lnR w="0">
-                      <a:noFill/>
-                    </a:lnR>
-                    <a:lnT w="0">
-                      <a:noFill/>
-                    </a:lnT>
-                    <a:lnB w="9525">
-                      <a:solidFill>
-                        <a:srgbClr val="D5DEE7"/>
-                      </a:solidFill>
-                    </a:lnB>
-                    <a:solidFill>
-                      <a:srgbClr val="FBECEE"/>
-                    </a:solidFill>
-                  </a:tcPr>
-                </a:tc>
-                <a:tc>
-                  <a:txBody>
-                    <a:bodyPr/>
-                    <a:lstStyle/>
-                    <a:p>
-                      <a:pPr algn="r"/>
-                      <a:r>
-                        <a:rPr sz="1600" b="1">
-                          <a:solidFill>
-                            <a:srgbClr val="B83B48"/>
-                          </a:solidFill>
-                          <a:latin typeface="Nimbus Sans"/>
-                          <a:ea typeface="Nimbus Sans"/>
-                          <a:cs typeface="Nimbus Sans"/>
-                        </a:rPr>
-                        <a:t>-9.74%</a:t>
-                      </a:r>
-                    </a:p>
-                  </a:txBody>
-                  <a:tcPr marL="109728" marR="109728" marT="27432" marB="27432" anchor="ctr">
-                    <a:lnL w="0">
-                      <a:noFill/>
-                    </a:lnL>
-                    <a:lnR w="0">
-                      <a:noFill/>
-                    </a:lnR>
-                    <a:lnT w="0">
-                      <a:noFill/>
-                    </a:lnT>
-                    <a:lnB w="9525">
-                      <a:solidFill>
-                        <a:srgbClr val="D5DEE7"/>
-                      </a:solidFill>
-                    </a:lnB>
-                    <a:solidFill>
-                      <a:srgbClr val="FBECEE"/>
-                    </a:solidFill>
-                  </a:tcPr>
-                </a:tc>
-              </a:tr>
-              <a:tr h="338328">
-                <a:tc vMerge="1">
-                  <a:txBody>
-                    <a:bodyPr/>
-                    <a:lstStyle/>
-                    <a:p/>
-                  </a:txBody>
-                  <a:tcPr/>
-                </a:tc>
-                <a:tc>
-                  <a:txBody>
-                    <a:bodyPr/>
-                    <a:lstStyle/>
-                    <a:p>
-                      <a:pPr algn="l"/>
-                      <a:r>
-                        <a:rPr sz="1600" b="1">
-                          <a:solidFill>
-                            <a:srgbClr val="12304D"/>
-                          </a:solidFill>
-                          <a:latin typeface="Nimbus Sans"/>
-                          <a:ea typeface="Nimbus Sans"/>
-                          <a:cs typeface="Nimbus Sans"/>
-                        </a:rPr>
-                        <a:t>Déficit de crecimiento de cartera</a:t>
-                      </a:r>
-                    </a:p>
-                  </a:txBody>
-                  <a:tcPr marL="109728" marR="109728" marT="27432" marB="27432" anchor="ctr">
-                    <a:lnL w="0">
-                      <a:noFill/>
-                    </a:lnL>
-                    <a:lnR w="0">
-                      <a:noFill/>
-                    </a:lnR>
-                    <a:lnT w="0">
-                      <a:noFill/>
-                    </a:lnT>
-                    <a:lnB w="9525">
-                      <a:solidFill>
-                        <a:srgbClr val="D5DEE7"/>
-                      </a:solidFill>
-                    </a:lnB>
-                    <a:solidFill>
-                      <a:srgbClr val="FBECEE"/>
-                    </a:solidFill>
-                  </a:tcPr>
-                </a:tc>
-                <a:tc>
-                  <a:txBody>
-                    <a:bodyPr/>
-                    <a:lstStyle/>
-                    <a:p>
-                      <a:pPr algn="r"/>
-                      <a:r>
-                        <a:rPr sz="1600" b="1">
-                          <a:solidFill>
-                            <a:srgbClr val="B83B48"/>
-                          </a:solidFill>
-                          <a:latin typeface="Nimbus Sans"/>
-                          <a:ea typeface="Nimbus Sans"/>
-                          <a:cs typeface="Nimbus Sans"/>
-                        </a:rPr>
-                        <a:t>−$3,238,328.18</a:t>
-                      </a:r>
-                    </a:p>
-                  </a:txBody>
-                  <a:tcPr marL="109728" marR="109728" marT="27432" marB="27432" anchor="ctr">
-                    <a:lnL w="0">
-                      <a:noFill/>
-                    </a:lnL>
-                    <a:lnR w="0">
-                      <a:noFill/>
-                    </a:lnR>
-                    <a:lnT w="0">
-                      <a:noFill/>
-                    </a:lnT>
-                    <a:lnB w="9525">
-                      <a:solidFill>
-                        <a:srgbClr val="D5DEE7"/>
-                      </a:solidFill>
-                    </a:lnB>
-                    <a:solidFill>
-                      <a:srgbClr val="FBECEE"/>
-                    </a:solidFill>
-                  </a:tcPr>
-                </a:tc>
-                <a:tc>
-                  <a:txBody>
-                    <a:bodyPr/>
-                    <a:lstStyle/>
-                    <a:p>
-                      <a:pPr algn="r"/>
-                      <a:r>
-                        <a:rPr sz="1600" b="1">
-                          <a:solidFill>
-                            <a:srgbClr val="B83B48"/>
-                          </a:solidFill>
-                          <a:latin typeface="Nimbus Sans"/>
-                          <a:ea typeface="Nimbus Sans"/>
-                          <a:cs typeface="Nimbus Sans"/>
-                        </a:rPr>
-                        <a:t>−$952,023.45</a:t>
-                      </a:r>
-                    </a:p>
-                  </a:txBody>
-                  <a:tcPr marL="109728" marR="109728" marT="27432" marB="27432" anchor="ctr">
-                    <a:lnL w="0">
-                      <a:noFill/>
-                    </a:lnL>
-                    <a:lnR w="0">
-                      <a:noFill/>
-                    </a:lnR>
-                    <a:lnT w="0">
-                      <a:noFill/>
-                    </a:lnT>
-                    <a:lnB w="9525">
-                      <a:solidFill>
-                        <a:srgbClr val="D5DEE7"/>
-                      </a:solidFill>
-                    </a:lnB>
-                    <a:solidFill>
-                      <a:srgbClr val="FBECEE"/>
-                    </a:solidFill>
-                  </a:tcPr>
-                </a:tc>
-              </a:tr>
-            </a:tbl>
-          </a:graphicData>
-        </a:graphic>
-      </p:graphicFrame>
+        </p:nvSpPr>
+        <p:spPr>
+          <a:xfrm>
+            <a:off x="475488" y="1417320"/>
+            <a:ext cx="5486400" cy="5120640"/>
+          </a:xfrm>
+          <a:prstGeom prst="roundRect">
+            <a:avLst>
+              <a:gd name="adj" fmla="val 4000"/>
+            </a:avLst>
+          </a:prstGeom>
+          <a:solidFill>
+            <a:srgbClr val="F3F6F9"/>
+          </a:solidFill>
+          <a:ln>
+            <a:noFill/>
+          </a:ln>
+        </p:spPr>
+        <p:style>
+          <a:lnRef idx="1">
+            <a:schemeClr val="accent1"/>
+          </a:lnRef>
+          <a:fillRef idx="3">
+            <a:schemeClr val="accent1"/>
+          </a:fillRef>
+          <a:effectRef idx="2">
+            <a:schemeClr val="accent1"/>
+          </a:effectRef>
+          <a:fontRef idx="minor">
+            <a:schemeClr val="lt1"/>
+          </a:fontRef>
+        </p:style>
+        <p:txBody>
+          <a:bodyPr rtlCol="0" anchor="ctr"/>
+          <a:lstStyle/>
+          <a:p>
+            <a:pPr algn="ctr"/>
+          </a:p>
+        </p:txBody>
+      </p:sp>
+      <p:sp>
+        <p:nvSpPr>
+          <p:cNvPr id="8" name="TextBox 7"/>
+          <p:cNvSpPr txBox="1"/>
+          <p:nvPr/>
+        </p:nvSpPr>
+        <p:spPr>
+          <a:xfrm>
+            <a:off x="749808" y="1600200"/>
+            <a:ext cx="4937760" cy="365760"/>
+          </a:xfrm>
+          <a:prstGeom prst="rect">
+            <a:avLst/>
+          </a:prstGeom>
+          <a:noFill/>
+        </p:spPr>
+        <p:txBody>
+          <a:bodyPr wrap="square" anchor="t" lIns="0" rIns="0" tIns="0" bIns="0">
+            <a:spAutoFit/>
+          </a:bodyPr>
+          <a:lstStyle/>
+          <a:p>
+            <a:pPr algn="l"/>
+            <a:r>
+              <a:rPr sz="2000" b="1">
+                <a:solidFill>
+                  <a:srgbClr val="12304D"/>
+                </a:solidFill>
+                <a:latin typeface="Nimbus Sans"/>
+                <a:ea typeface="Nimbus Sans"/>
+                <a:cs typeface="Nimbus Sans"/>
+              </a:rPr>
+              <a:t>Central</a:t>
+            </a:r>
+          </a:p>
+        </p:txBody>
+      </p:sp>
+      <p:sp>
+        <p:nvSpPr>
+          <p:cNvPr id="9" name="Oval 8"/>
+          <p:cNvSpPr/>
+          <p:nvPr/>
+        </p:nvSpPr>
+        <p:spPr>
+          <a:xfrm>
+            <a:off x="749808" y="2075688"/>
+            <a:ext cx="256032" cy="256032"/>
+          </a:xfrm>
+          <a:prstGeom prst="ellipse">
+            <a:avLst/>
+          </a:prstGeom>
+          <a:solidFill>
+            <a:srgbClr val="12304D"/>
+          </a:solidFill>
+          <a:ln>
+            <a:noFill/>
+          </a:ln>
+        </p:spPr>
+        <p:style>
+          <a:lnRef idx="1">
+            <a:schemeClr val="accent1"/>
+          </a:lnRef>
+          <a:fillRef idx="3">
+            <a:schemeClr val="accent1"/>
+          </a:fillRef>
+          <a:effectRef idx="2">
+            <a:schemeClr val="accent1"/>
+          </a:effectRef>
+          <a:fontRef idx="minor">
+            <a:schemeClr val="lt1"/>
+          </a:fontRef>
+        </p:style>
+        <p:txBody>
+          <a:bodyPr rtlCol="0" anchor="ctr" lIns="0" rIns="0" tIns="0" bIns="0"/>
+          <a:lstStyle/>
+          <a:p>
+            <a:pPr algn="ctr"/>
+            <a:r>
+              <a:rPr sz="1300" b="1">
+                <a:solidFill>
+                  <a:srgbClr val="FFFFFF"/>
+                </a:solidFill>
+                <a:latin typeface="Nimbus Sans"/>
+                <a:ea typeface="Nimbus Sans"/>
+                <a:cs typeface="Nimbus Sans"/>
+              </a:rPr>
+              <a:t>1</a:t>
+            </a:r>
+          </a:p>
+        </p:txBody>
+      </p:sp>
+      <p:sp>
+        <p:nvSpPr>
+          <p:cNvPr id="10" name="TextBox 9"/>
+          <p:cNvSpPr txBox="1"/>
+          <p:nvPr/>
+        </p:nvSpPr>
+        <p:spPr>
+          <a:xfrm>
+            <a:off x="1115568" y="2075688"/>
+            <a:ext cx="4572000" cy="256032"/>
+          </a:xfrm>
+          <a:prstGeom prst="rect">
+            <a:avLst/>
+          </a:prstGeom>
+          <a:noFill/>
+        </p:spPr>
+        <p:txBody>
+          <a:bodyPr wrap="square" anchor="ctr" lIns="0" rIns="0" tIns="0" bIns="0">
+            <a:spAutoFit/>
+          </a:bodyPr>
+          <a:lstStyle/>
+          <a:p>
+            <a:pPr algn="l"/>
+            <a:r>
+              <a:rPr sz="1100" b="1">
+                <a:solidFill>
+                  <a:srgbClr val="2C79A8"/>
+                </a:solidFill>
+                <a:latin typeface="Nimbus Sans"/>
+                <a:ea typeface="Nimbus Sans"/>
+                <a:cs typeface="Nimbus Sans"/>
+              </a:rPr>
+              <a:t>DESEMBOLSOS</a:t>
+            </a:r>
+          </a:p>
+        </p:txBody>
+      </p:sp>
+      <p:sp>
+        <p:nvSpPr>
+          <p:cNvPr id="11" name="TextBox 10"/>
+          <p:cNvSpPr txBox="1"/>
+          <p:nvPr/>
+        </p:nvSpPr>
+        <p:spPr>
+          <a:xfrm>
+            <a:off x="749808" y="2459736"/>
+            <a:ext cx="2377440" cy="384048"/>
+          </a:xfrm>
+          <a:prstGeom prst="rect">
+            <a:avLst/>
+          </a:prstGeom>
+          <a:noFill/>
+        </p:spPr>
+        <p:txBody>
+          <a:bodyPr wrap="square" anchor="t" lIns="0" rIns="0" tIns="0" bIns="0">
+            <a:spAutoFit/>
+          </a:bodyPr>
+          <a:lstStyle/>
+          <a:p>
+            <a:pPr algn="l"/>
+            <a:r>
+              <a:rPr sz="2400" b="1">
+                <a:solidFill>
+                  <a:srgbClr val="1F6B4A"/>
+                </a:solidFill>
+                <a:latin typeface="Nimbus Sans"/>
+                <a:ea typeface="Nimbus Sans"/>
+                <a:cs typeface="Nimbus Sans"/>
+              </a:rPr>
+              <a:t>124.17%</a:t>
+            </a:r>
+          </a:p>
+        </p:txBody>
+      </p:sp>
+      <p:sp>
+        <p:nvSpPr>
+          <p:cNvPr id="12" name="TextBox 11"/>
+          <p:cNvSpPr txBox="1"/>
+          <p:nvPr/>
+        </p:nvSpPr>
+        <p:spPr>
+          <a:xfrm>
+            <a:off x="749808" y="2871216"/>
+            <a:ext cx="2377440" cy="228600"/>
+          </a:xfrm>
+          <a:prstGeom prst="rect">
+            <a:avLst/>
+          </a:prstGeom>
+          <a:noFill/>
+        </p:spPr>
+        <p:txBody>
+          <a:bodyPr wrap="square" anchor="t" lIns="0" rIns="0" tIns="0" bIns="0">
+            <a:spAutoFit/>
+          </a:bodyPr>
+          <a:lstStyle/>
+          <a:p>
+            <a:pPr algn="l"/>
+            <a:r>
+              <a:rPr sz="1050" b="0">
+                <a:solidFill>
+                  <a:srgbClr val="12304D"/>
+                </a:solidFill>
+                <a:latin typeface="Nimbus Sans"/>
+                <a:ea typeface="Nimbus Sans"/>
+                <a:cs typeface="Nimbus Sans"/>
+              </a:rPr>
+              <a:t>Cumplimiento de desembolsos</a:t>
+            </a:r>
+          </a:p>
+        </p:txBody>
+      </p:sp>
+      <p:sp>
+        <p:nvSpPr>
+          <p:cNvPr id="13" name="TextBox 12"/>
+          <p:cNvSpPr txBox="1"/>
+          <p:nvPr/>
+        </p:nvSpPr>
+        <p:spPr>
+          <a:xfrm>
+            <a:off x="3264408" y="2459736"/>
+            <a:ext cx="2423160" cy="182880"/>
+          </a:xfrm>
+          <a:prstGeom prst="rect">
+            <a:avLst/>
+          </a:prstGeom>
+          <a:noFill/>
+        </p:spPr>
+        <p:txBody>
+          <a:bodyPr wrap="square" anchor="t" lIns="0" rIns="0" tIns="0" bIns="0">
+            <a:spAutoFit/>
+          </a:bodyPr>
+          <a:lstStyle/>
+          <a:p>
+            <a:pPr algn="l"/>
+            <a:r>
+              <a:rPr sz="1050" b="0">
+                <a:solidFill>
+                  <a:srgbClr val="5A6878"/>
+                </a:solidFill>
+                <a:latin typeface="Nimbus Sans"/>
+                <a:ea typeface="Nimbus Sans"/>
+                <a:cs typeface="Nimbus Sans"/>
+              </a:rPr>
+              <a:t>Meta de desembolsos</a:t>
+            </a:r>
+          </a:p>
+        </p:txBody>
+      </p:sp>
+      <p:sp>
+        <p:nvSpPr>
+          <p:cNvPr id="14" name="TextBox 13"/>
+          <p:cNvSpPr txBox="1"/>
+          <p:nvPr/>
+        </p:nvSpPr>
+        <p:spPr>
+          <a:xfrm>
+            <a:off x="3264408" y="2633472"/>
+            <a:ext cx="2423160" cy="228600"/>
+          </a:xfrm>
+          <a:prstGeom prst="rect">
+            <a:avLst/>
+          </a:prstGeom>
+          <a:noFill/>
+        </p:spPr>
+        <p:txBody>
+          <a:bodyPr wrap="square" anchor="t" lIns="0" rIns="0" tIns="0" bIns="0">
+            <a:spAutoFit/>
+          </a:bodyPr>
+          <a:lstStyle/>
+          <a:p>
+            <a:pPr algn="l"/>
+            <a:r>
+              <a:rPr sz="1250" b="0">
+                <a:solidFill>
+                  <a:srgbClr val="5A6878"/>
+                </a:solidFill>
+                <a:latin typeface="Nimbus Sans"/>
+                <a:ea typeface="Nimbus Sans"/>
+                <a:cs typeface="Nimbus Sans"/>
+              </a:rPr>
+              <a:t>$8,100,000.00</a:t>
+            </a:r>
+          </a:p>
+        </p:txBody>
+      </p:sp>
+      <p:sp>
+        <p:nvSpPr>
+          <p:cNvPr id="15" name="TextBox 14"/>
+          <p:cNvSpPr txBox="1"/>
+          <p:nvPr/>
+        </p:nvSpPr>
+        <p:spPr>
+          <a:xfrm>
+            <a:off x="3264408" y="2889504"/>
+            <a:ext cx="2423160" cy="182880"/>
+          </a:xfrm>
+          <a:prstGeom prst="rect">
+            <a:avLst/>
+          </a:prstGeom>
+          <a:noFill/>
+        </p:spPr>
+        <p:txBody>
+          <a:bodyPr wrap="square" anchor="t" lIns="0" rIns="0" tIns="0" bIns="0">
+            <a:spAutoFit/>
+          </a:bodyPr>
+          <a:lstStyle/>
+          <a:p>
+            <a:pPr algn="l"/>
+            <a:r>
+              <a:rPr sz="1050" b="0">
+                <a:solidFill>
+                  <a:srgbClr val="5A6878"/>
+                </a:solidFill>
+                <a:latin typeface="Nimbus Sans"/>
+                <a:ea typeface="Nimbus Sans"/>
+                <a:cs typeface="Nimbus Sans"/>
+              </a:rPr>
+              <a:t>Desembolsos realizados (+)</a:t>
+            </a:r>
+          </a:p>
+        </p:txBody>
+      </p:sp>
+      <p:sp>
+        <p:nvSpPr>
+          <p:cNvPr id="16" name="TextBox 15"/>
+          <p:cNvSpPr txBox="1"/>
+          <p:nvPr/>
+        </p:nvSpPr>
+        <p:spPr>
+          <a:xfrm>
+            <a:off x="3264408" y="3063240"/>
+            <a:ext cx="2423160" cy="228600"/>
+          </a:xfrm>
+          <a:prstGeom prst="rect">
+            <a:avLst/>
+          </a:prstGeom>
+          <a:noFill/>
+        </p:spPr>
+        <p:txBody>
+          <a:bodyPr wrap="square" anchor="t" lIns="0" rIns="0" tIns="0" bIns="0">
+            <a:spAutoFit/>
+          </a:bodyPr>
+          <a:lstStyle/>
+          <a:p>
+            <a:pPr algn="l"/>
+            <a:r>
+              <a:rPr sz="1250" b="0">
+                <a:solidFill>
+                  <a:srgbClr val="5A6878"/>
+                </a:solidFill>
+                <a:latin typeface="Nimbus Sans"/>
+                <a:ea typeface="Nimbus Sans"/>
+                <a:cs typeface="Nimbus Sans"/>
+              </a:rPr>
+              <a:t>$10,057,790.62</a:t>
+            </a:r>
+          </a:p>
+        </p:txBody>
+      </p:sp>
+      <p:cxnSp>
+        <p:nvCxnSpPr>
+          <p:cNvPr id="17" name="Connector 16"/>
+          <p:cNvCxnSpPr/>
+          <p:nvPr/>
+        </p:nvCxnSpPr>
+        <p:spPr>
+          <a:xfrm>
+            <a:off x="749808" y="3282696"/>
+            <a:ext cx="4937760" cy="0"/>
+          </a:xfrm>
+          <a:prstGeom prst="line">
+            <a:avLst/>
+          </a:prstGeom>
+          <a:ln w="9525">
+            <a:solidFill>
+              <a:srgbClr val="DCE3EA"/>
+            </a:solidFill>
+          </a:ln>
+        </p:spPr>
+        <p:style>
+          <a:lnRef idx="2">
+            <a:schemeClr val="accent1"/>
+          </a:lnRef>
+          <a:fillRef idx="0">
+            <a:schemeClr val="accent1"/>
+          </a:fillRef>
+          <a:effectRef idx="1">
+            <a:schemeClr val="accent1"/>
+          </a:effectRef>
+          <a:fontRef idx="minor">
+            <a:schemeClr val="tx1"/>
+          </a:fontRef>
+        </p:style>
+      </p:cxnSp>
+      <p:sp>
+        <p:nvSpPr>
+          <p:cNvPr id="18" name="Oval 17"/>
+          <p:cNvSpPr/>
+          <p:nvPr/>
+        </p:nvSpPr>
+        <p:spPr>
+          <a:xfrm>
+            <a:off x="749808" y="3401568"/>
+            <a:ext cx="256032" cy="256032"/>
+          </a:xfrm>
+          <a:prstGeom prst="ellipse">
+            <a:avLst/>
+          </a:prstGeom>
+          <a:solidFill>
+            <a:srgbClr val="12304D"/>
+          </a:solidFill>
+          <a:ln>
+            <a:noFill/>
+          </a:ln>
+        </p:spPr>
+        <p:style>
+          <a:lnRef idx="1">
+            <a:schemeClr val="accent1"/>
+          </a:lnRef>
+          <a:fillRef idx="3">
+            <a:schemeClr val="accent1"/>
+          </a:fillRef>
+          <a:effectRef idx="2">
+            <a:schemeClr val="accent1"/>
+          </a:effectRef>
+          <a:fontRef idx="minor">
+            <a:schemeClr val="lt1"/>
+          </a:fontRef>
+        </p:style>
+        <p:txBody>
+          <a:bodyPr rtlCol="0" anchor="ctr" lIns="0" rIns="0" tIns="0" bIns="0"/>
+          <a:lstStyle/>
+          <a:p>
+            <a:pPr algn="ctr"/>
+            <a:r>
+              <a:rPr sz="1300" b="1">
+                <a:solidFill>
+                  <a:srgbClr val="FFFFFF"/>
+                </a:solidFill>
+                <a:latin typeface="Nimbus Sans"/>
+                <a:ea typeface="Nimbus Sans"/>
+                <a:cs typeface="Nimbus Sans"/>
+              </a:rPr>
+              <a:t>2</a:t>
+            </a:r>
+          </a:p>
+        </p:txBody>
+      </p:sp>
+      <p:sp>
+        <p:nvSpPr>
+          <p:cNvPr id="19" name="TextBox 18"/>
+          <p:cNvSpPr txBox="1"/>
+          <p:nvPr/>
+        </p:nvSpPr>
+        <p:spPr>
+          <a:xfrm>
+            <a:off x="1115568" y="3401568"/>
+            <a:ext cx="4572000" cy="256032"/>
+          </a:xfrm>
+          <a:prstGeom prst="rect">
+            <a:avLst/>
+          </a:prstGeom>
+          <a:noFill/>
+        </p:spPr>
+        <p:txBody>
+          <a:bodyPr wrap="square" anchor="ctr" lIns="0" rIns="0" tIns="0" bIns="0">
+            <a:spAutoFit/>
+          </a:bodyPr>
+          <a:lstStyle/>
+          <a:p>
+            <a:pPr algn="l"/>
+            <a:r>
+              <a:rPr sz="1100" b="1">
+                <a:solidFill>
+                  <a:srgbClr val="2C79A8"/>
+                </a:solidFill>
+                <a:latin typeface="Nimbus Sans"/>
+                <a:ea typeface="Nimbus Sans"/>
+                <a:cs typeface="Nimbus Sans"/>
+              </a:rPr>
+              <a:t>COLOCACIÓN NETA</a:t>
+            </a:r>
+          </a:p>
+        </p:txBody>
+      </p:sp>
+      <p:sp>
+        <p:nvSpPr>
+          <p:cNvPr id="20" name="TextBox 19"/>
+          <p:cNvSpPr txBox="1"/>
+          <p:nvPr/>
+        </p:nvSpPr>
+        <p:spPr>
+          <a:xfrm>
+            <a:off x="749808" y="3785615"/>
+            <a:ext cx="2377440" cy="384048"/>
+          </a:xfrm>
+          <a:prstGeom prst="rect">
+            <a:avLst/>
+          </a:prstGeom>
+          <a:noFill/>
+        </p:spPr>
+        <p:txBody>
+          <a:bodyPr wrap="square" anchor="t" lIns="0" rIns="0" tIns="0" bIns="0">
+            <a:spAutoFit/>
+          </a:bodyPr>
+          <a:lstStyle/>
+          <a:p>
+            <a:pPr algn="l"/>
+            <a:r>
+              <a:rPr sz="2400" b="1">
+                <a:solidFill>
+                  <a:srgbClr val="1F6B4A"/>
+                </a:solidFill>
+                <a:latin typeface="Nimbus Sans"/>
+                <a:ea typeface="Nimbus Sans"/>
+                <a:cs typeface="Nimbus Sans"/>
+              </a:rPr>
+              <a:t>$885,133.63</a:t>
+            </a:r>
+          </a:p>
+        </p:txBody>
+      </p:sp>
+      <p:sp>
+        <p:nvSpPr>
+          <p:cNvPr id="21" name="TextBox 20"/>
+          <p:cNvSpPr txBox="1"/>
+          <p:nvPr/>
+        </p:nvSpPr>
+        <p:spPr>
+          <a:xfrm>
+            <a:off x="749808" y="4197096"/>
+            <a:ext cx="2377440" cy="228600"/>
+          </a:xfrm>
+          <a:prstGeom prst="rect">
+            <a:avLst/>
+          </a:prstGeom>
+          <a:noFill/>
+        </p:spPr>
+        <p:txBody>
+          <a:bodyPr wrap="square" anchor="t" lIns="0" rIns="0" tIns="0" bIns="0">
+            <a:spAutoFit/>
+          </a:bodyPr>
+          <a:lstStyle/>
+          <a:p>
+            <a:pPr algn="l"/>
+            <a:r>
+              <a:rPr sz="1050" b="0">
+                <a:solidFill>
+                  <a:srgbClr val="12304D"/>
+                </a:solidFill>
+                <a:latin typeface="Nimbus Sans"/>
+                <a:ea typeface="Nimbus Sans"/>
+                <a:cs typeface="Nimbus Sans"/>
+              </a:rPr>
+              <a:t>Colocación Neta de desembolsos</a:t>
+            </a:r>
+          </a:p>
+        </p:txBody>
+      </p:sp>
+      <p:sp>
+        <p:nvSpPr>
+          <p:cNvPr id="22" name="TextBox 21"/>
+          <p:cNvSpPr txBox="1"/>
+          <p:nvPr/>
+        </p:nvSpPr>
+        <p:spPr>
+          <a:xfrm>
+            <a:off x="3264408" y="3785615"/>
+            <a:ext cx="2423160" cy="182880"/>
+          </a:xfrm>
+          <a:prstGeom prst="rect">
+            <a:avLst/>
+          </a:prstGeom>
+          <a:noFill/>
+        </p:spPr>
+        <p:txBody>
+          <a:bodyPr wrap="square" anchor="t" lIns="0" rIns="0" tIns="0" bIns="0">
+            <a:spAutoFit/>
+          </a:bodyPr>
+          <a:lstStyle/>
+          <a:p>
+            <a:pPr algn="l"/>
+            <a:r>
+              <a:rPr sz="1050" b="0">
+                <a:solidFill>
+                  <a:srgbClr val="5A6878"/>
+                </a:solidFill>
+                <a:latin typeface="Nimbus Sans"/>
+                <a:ea typeface="Nimbus Sans"/>
+                <a:cs typeface="Nimbus Sans"/>
+              </a:rPr>
+              <a:t>Amortización natural (−)</a:t>
+            </a:r>
+          </a:p>
+        </p:txBody>
+      </p:sp>
+      <p:sp>
+        <p:nvSpPr>
+          <p:cNvPr id="23" name="TextBox 22"/>
+          <p:cNvSpPr txBox="1"/>
+          <p:nvPr/>
+        </p:nvSpPr>
+        <p:spPr>
+          <a:xfrm>
+            <a:off x="3264408" y="3959352"/>
+            <a:ext cx="2423160" cy="228600"/>
+          </a:xfrm>
+          <a:prstGeom prst="rect">
+            <a:avLst/>
+          </a:prstGeom>
+          <a:noFill/>
+        </p:spPr>
+        <p:txBody>
+          <a:bodyPr wrap="square" anchor="t" lIns="0" rIns="0" tIns="0" bIns="0">
+            <a:spAutoFit/>
+          </a:bodyPr>
+          <a:lstStyle/>
+          <a:p>
+            <a:pPr algn="l"/>
+            <a:r>
+              <a:rPr sz="1250" b="0">
+                <a:solidFill>
+                  <a:srgbClr val="5A6878"/>
+                </a:solidFill>
+                <a:latin typeface="Nimbus Sans"/>
+                <a:ea typeface="Nimbus Sans"/>
+                <a:cs typeface="Nimbus Sans"/>
+              </a:rPr>
+              <a:t>$4,704,882.17</a:t>
+            </a:r>
+          </a:p>
+        </p:txBody>
+      </p:sp>
+      <p:sp>
+        <p:nvSpPr>
+          <p:cNvPr id="24" name="TextBox 23"/>
+          <p:cNvSpPr txBox="1"/>
+          <p:nvPr/>
+        </p:nvSpPr>
+        <p:spPr>
+          <a:xfrm>
+            <a:off x="3264408" y="4215383"/>
+            <a:ext cx="2423160" cy="182880"/>
+          </a:xfrm>
+          <a:prstGeom prst="rect">
+            <a:avLst/>
+          </a:prstGeom>
+          <a:noFill/>
+        </p:spPr>
+        <p:txBody>
+          <a:bodyPr wrap="square" anchor="t" lIns="0" rIns="0" tIns="0" bIns="0">
+            <a:spAutoFit/>
+          </a:bodyPr>
+          <a:lstStyle/>
+          <a:p>
+            <a:pPr algn="l"/>
+            <a:r>
+              <a:rPr sz="1050" b="0">
+                <a:solidFill>
+                  <a:srgbClr val="5A6878"/>
+                </a:solidFill>
+                <a:latin typeface="Nimbus Sans"/>
+                <a:ea typeface="Nimbus Sans"/>
+                <a:cs typeface="Nimbus Sans"/>
+              </a:rPr>
+              <a:t>Cancelaciones anticipadas (−)</a:t>
+            </a:r>
+          </a:p>
+        </p:txBody>
+      </p:sp>
+      <p:sp>
+        <p:nvSpPr>
+          <p:cNvPr id="25" name="TextBox 24"/>
+          <p:cNvSpPr txBox="1"/>
+          <p:nvPr/>
+        </p:nvSpPr>
+        <p:spPr>
+          <a:xfrm>
+            <a:off x="3264408" y="4389120"/>
+            <a:ext cx="2423160" cy="228600"/>
+          </a:xfrm>
+          <a:prstGeom prst="rect">
+            <a:avLst/>
+          </a:prstGeom>
+          <a:noFill/>
+        </p:spPr>
+        <p:txBody>
+          <a:bodyPr wrap="square" anchor="t" lIns="0" rIns="0" tIns="0" bIns="0">
+            <a:spAutoFit/>
+          </a:bodyPr>
+          <a:lstStyle/>
+          <a:p>
+            <a:pPr algn="l"/>
+            <a:r>
+              <a:rPr sz="1250" b="0">
+                <a:solidFill>
+                  <a:srgbClr val="5A6878"/>
+                </a:solidFill>
+                <a:latin typeface="Nimbus Sans"/>
+                <a:ea typeface="Nimbus Sans"/>
+                <a:cs typeface="Nimbus Sans"/>
+              </a:rPr>
+              <a:t>$4,467,774.82</a:t>
+            </a:r>
+          </a:p>
+        </p:txBody>
+      </p:sp>
+      <p:cxnSp>
+        <p:nvCxnSpPr>
+          <p:cNvPr id="26" name="Connector 25"/>
+          <p:cNvCxnSpPr/>
+          <p:nvPr/>
+        </p:nvCxnSpPr>
+        <p:spPr>
+          <a:xfrm>
+            <a:off x="749808" y="4608576"/>
+            <a:ext cx="4937760" cy="0"/>
+          </a:xfrm>
+          <a:prstGeom prst="line">
+            <a:avLst/>
+          </a:prstGeom>
+          <a:ln w="9525">
+            <a:solidFill>
+              <a:srgbClr val="DCE3EA"/>
+            </a:solidFill>
+          </a:ln>
+        </p:spPr>
+        <p:style>
+          <a:lnRef idx="2">
+            <a:schemeClr val="accent1"/>
+          </a:lnRef>
+          <a:fillRef idx="0">
+            <a:schemeClr val="accent1"/>
+          </a:fillRef>
+          <a:effectRef idx="1">
+            <a:schemeClr val="accent1"/>
+          </a:effectRef>
+          <a:fontRef idx="minor">
+            <a:schemeClr val="tx1"/>
+          </a:fontRef>
+        </p:style>
+      </p:cxnSp>
+      <p:sp>
+        <p:nvSpPr>
+          <p:cNvPr id="27" name="Oval 26"/>
+          <p:cNvSpPr/>
+          <p:nvPr/>
+        </p:nvSpPr>
+        <p:spPr>
+          <a:xfrm>
+            <a:off x="749808" y="4727448"/>
+            <a:ext cx="256032" cy="256032"/>
+          </a:xfrm>
+          <a:prstGeom prst="ellipse">
+            <a:avLst/>
+          </a:prstGeom>
+          <a:solidFill>
+            <a:srgbClr val="12304D"/>
+          </a:solidFill>
+          <a:ln>
+            <a:noFill/>
+          </a:ln>
+        </p:spPr>
+        <p:style>
+          <a:lnRef idx="1">
+            <a:schemeClr val="accent1"/>
+          </a:lnRef>
+          <a:fillRef idx="3">
+            <a:schemeClr val="accent1"/>
+          </a:fillRef>
+          <a:effectRef idx="2">
+            <a:schemeClr val="accent1"/>
+          </a:effectRef>
+          <a:fontRef idx="minor">
+            <a:schemeClr val="lt1"/>
+          </a:fontRef>
+        </p:style>
+        <p:txBody>
+          <a:bodyPr rtlCol="0" anchor="ctr" lIns="0" rIns="0" tIns="0" bIns="0"/>
+          <a:lstStyle/>
+          <a:p>
+            <a:pPr algn="ctr"/>
+            <a:r>
+              <a:rPr sz="1300" b="1">
+                <a:solidFill>
+                  <a:srgbClr val="FFFFFF"/>
+                </a:solidFill>
+                <a:latin typeface="Nimbus Sans"/>
+                <a:ea typeface="Nimbus Sans"/>
+                <a:cs typeface="Nimbus Sans"/>
+              </a:rPr>
+              <a:t>3</a:t>
+            </a:r>
+          </a:p>
+        </p:txBody>
+      </p:sp>
+      <p:sp>
+        <p:nvSpPr>
+          <p:cNvPr id="28" name="TextBox 27"/>
+          <p:cNvSpPr txBox="1"/>
+          <p:nvPr/>
+        </p:nvSpPr>
+        <p:spPr>
+          <a:xfrm>
+            <a:off x="1115568" y="4727448"/>
+            <a:ext cx="4572000" cy="256032"/>
+          </a:xfrm>
+          <a:prstGeom prst="rect">
+            <a:avLst/>
+          </a:prstGeom>
+          <a:noFill/>
+        </p:spPr>
+        <p:txBody>
+          <a:bodyPr wrap="square" anchor="ctr" lIns="0" rIns="0" tIns="0" bIns="0">
+            <a:spAutoFit/>
+          </a:bodyPr>
+          <a:lstStyle/>
+          <a:p>
+            <a:pPr algn="l"/>
+            <a:r>
+              <a:rPr sz="1100" b="1">
+                <a:solidFill>
+                  <a:srgbClr val="2C79A8"/>
+                </a:solidFill>
+                <a:latin typeface="Nimbus Sans"/>
+                <a:ea typeface="Nimbus Sans"/>
+                <a:cs typeface="Nimbus Sans"/>
+              </a:rPr>
+              <a:t>CRECIMIENTO DE CARTERA</a:t>
+            </a:r>
+          </a:p>
+        </p:txBody>
+      </p:sp>
+      <p:sp>
+        <p:nvSpPr>
+          <p:cNvPr id="29" name="TextBox 28"/>
+          <p:cNvSpPr txBox="1"/>
+          <p:nvPr/>
+        </p:nvSpPr>
+        <p:spPr>
+          <a:xfrm>
+            <a:off x="749808" y="5111496"/>
+            <a:ext cx="1554480" cy="292608"/>
+          </a:xfrm>
+          <a:prstGeom prst="rect">
+            <a:avLst/>
+          </a:prstGeom>
+          <a:noFill/>
+        </p:spPr>
+        <p:txBody>
+          <a:bodyPr wrap="square" anchor="t" lIns="0" rIns="0" tIns="0" bIns="0">
+            <a:spAutoFit/>
+          </a:bodyPr>
+          <a:lstStyle/>
+          <a:p>
+            <a:pPr algn="l"/>
+            <a:r>
+              <a:rPr sz="1600" b="1">
+                <a:solidFill>
+                  <a:srgbClr val="B83B48"/>
+                </a:solidFill>
+                <a:latin typeface="Nimbus Sans"/>
+                <a:ea typeface="Nimbus Sans"/>
+                <a:cs typeface="Nimbus Sans"/>
+              </a:rPr>
+              <a:t>−$845,243.40</a:t>
+            </a:r>
+          </a:p>
+        </p:txBody>
+      </p:sp>
+      <p:sp>
+        <p:nvSpPr>
+          <p:cNvPr id="30" name="TextBox 29"/>
+          <p:cNvSpPr txBox="1"/>
+          <p:nvPr/>
+        </p:nvSpPr>
+        <p:spPr>
+          <a:xfrm>
+            <a:off x="749808" y="5404104"/>
+            <a:ext cx="1536192" cy="329184"/>
+          </a:xfrm>
+          <a:prstGeom prst="rect">
+            <a:avLst/>
+          </a:prstGeom>
+          <a:noFill/>
+        </p:spPr>
+        <p:txBody>
+          <a:bodyPr wrap="square" anchor="t" lIns="0" rIns="0" tIns="0" bIns="0">
+            <a:spAutoFit/>
+          </a:bodyPr>
+          <a:lstStyle/>
+          <a:p>
+            <a:pPr algn="l"/>
+            <a:r>
+              <a:rPr sz="1000" b="0">
+                <a:solidFill>
+                  <a:srgbClr val="12304D"/>
+                </a:solidFill>
+                <a:latin typeface="Nimbus Sans"/>
+                <a:ea typeface="Nimbus Sans"/>
+                <a:cs typeface="Nimbus Sans"/>
+              </a:rPr>
+              <a:t>Crecimiento de cartera</a:t>
+            </a:r>
+          </a:p>
+        </p:txBody>
+      </p:sp>
+      <p:sp>
+        <p:nvSpPr>
+          <p:cNvPr id="31" name="TextBox 30"/>
+          <p:cNvSpPr txBox="1"/>
+          <p:nvPr/>
+        </p:nvSpPr>
+        <p:spPr>
+          <a:xfrm>
+            <a:off x="2395728" y="5111496"/>
+            <a:ext cx="1554480" cy="292608"/>
+          </a:xfrm>
+          <a:prstGeom prst="rect">
+            <a:avLst/>
+          </a:prstGeom>
+          <a:noFill/>
+        </p:spPr>
+        <p:txBody>
+          <a:bodyPr wrap="square" anchor="t" lIns="0" rIns="0" tIns="0" bIns="0">
+            <a:spAutoFit/>
+          </a:bodyPr>
+          <a:lstStyle/>
+          <a:p>
+            <a:pPr algn="l"/>
+            <a:r>
+              <a:rPr sz="1600" b="1">
+                <a:solidFill>
+                  <a:srgbClr val="B83B48"/>
+                </a:solidFill>
+                <a:latin typeface="Nimbus Sans"/>
+                <a:ea typeface="Nimbus Sans"/>
+                <a:cs typeface="Nimbus Sans"/>
+              </a:rPr>
+              <a:t>-35.32%</a:t>
+            </a:r>
+          </a:p>
+        </p:txBody>
+      </p:sp>
+      <p:sp>
+        <p:nvSpPr>
+          <p:cNvPr id="32" name="TextBox 31"/>
+          <p:cNvSpPr txBox="1"/>
+          <p:nvPr/>
+        </p:nvSpPr>
+        <p:spPr>
+          <a:xfrm>
+            <a:off x="2395728" y="5404104"/>
+            <a:ext cx="1536192" cy="329184"/>
+          </a:xfrm>
+          <a:prstGeom prst="rect">
+            <a:avLst/>
+          </a:prstGeom>
+          <a:noFill/>
+        </p:spPr>
+        <p:txBody>
+          <a:bodyPr wrap="square" anchor="t" lIns="0" rIns="0" tIns="0" bIns="0">
+            <a:spAutoFit/>
+          </a:bodyPr>
+          <a:lstStyle/>
+          <a:p>
+            <a:pPr algn="l"/>
+            <a:r>
+              <a:rPr sz="1000" b="0">
+                <a:solidFill>
+                  <a:srgbClr val="12304D"/>
+                </a:solidFill>
+                <a:latin typeface="Nimbus Sans"/>
+                <a:ea typeface="Nimbus Sans"/>
+                <a:cs typeface="Nimbus Sans"/>
+              </a:rPr>
+              <a:t>Cumplimiento de la meta de crecimiento</a:t>
+            </a:r>
+          </a:p>
+        </p:txBody>
+      </p:sp>
+      <p:sp>
+        <p:nvSpPr>
+          <p:cNvPr id="33" name="TextBox 32"/>
+          <p:cNvSpPr txBox="1"/>
+          <p:nvPr/>
+        </p:nvSpPr>
+        <p:spPr>
+          <a:xfrm>
+            <a:off x="4041648" y="5111496"/>
+            <a:ext cx="1554480" cy="292608"/>
+          </a:xfrm>
+          <a:prstGeom prst="rect">
+            <a:avLst/>
+          </a:prstGeom>
+          <a:noFill/>
+        </p:spPr>
+        <p:txBody>
+          <a:bodyPr wrap="square" anchor="t" lIns="0" rIns="0" tIns="0" bIns="0">
+            <a:spAutoFit/>
+          </a:bodyPr>
+          <a:lstStyle/>
+          <a:p>
+            <a:pPr algn="l"/>
+            <a:r>
+              <a:rPr sz="1600" b="1">
+                <a:solidFill>
+                  <a:srgbClr val="B83B48"/>
+                </a:solidFill>
+                <a:latin typeface="Nimbus Sans"/>
+                <a:ea typeface="Nimbus Sans"/>
+                <a:cs typeface="Nimbus Sans"/>
+              </a:rPr>
+              <a:t>−$3,238,328.18</a:t>
+            </a:r>
+          </a:p>
+        </p:txBody>
+      </p:sp>
+      <p:sp>
+        <p:nvSpPr>
+          <p:cNvPr id="34" name="TextBox 33"/>
+          <p:cNvSpPr txBox="1"/>
+          <p:nvPr/>
+        </p:nvSpPr>
+        <p:spPr>
+          <a:xfrm>
+            <a:off x="4041648" y="5404104"/>
+            <a:ext cx="1536192" cy="329184"/>
+          </a:xfrm>
+          <a:prstGeom prst="rect">
+            <a:avLst/>
+          </a:prstGeom>
+          <a:noFill/>
+        </p:spPr>
+        <p:txBody>
+          <a:bodyPr wrap="square" anchor="t" lIns="0" rIns="0" tIns="0" bIns="0">
+            <a:spAutoFit/>
+          </a:bodyPr>
+          <a:lstStyle/>
+          <a:p>
+            <a:pPr algn="l"/>
+            <a:r>
+              <a:rPr sz="1000" b="0">
+                <a:solidFill>
+                  <a:srgbClr val="12304D"/>
+                </a:solidFill>
+                <a:latin typeface="Nimbus Sans"/>
+                <a:ea typeface="Nimbus Sans"/>
+                <a:cs typeface="Nimbus Sans"/>
+              </a:rPr>
+              <a:t>Déficit de crecimiento de cartera</a:t>
+            </a:r>
+          </a:p>
+        </p:txBody>
+      </p:sp>
+      <p:sp>
+        <p:nvSpPr>
+          <p:cNvPr id="35" name="TextBox 34"/>
+          <p:cNvSpPr txBox="1"/>
+          <p:nvPr/>
+        </p:nvSpPr>
+        <p:spPr>
+          <a:xfrm>
+            <a:off x="749808" y="5806440"/>
+            <a:ext cx="2743200" cy="182880"/>
+          </a:xfrm>
+          <a:prstGeom prst="rect">
+            <a:avLst/>
+          </a:prstGeom>
+          <a:noFill/>
+        </p:spPr>
+        <p:txBody>
+          <a:bodyPr wrap="square" anchor="t" lIns="0" rIns="0" tIns="0" bIns="0">
+            <a:spAutoFit/>
+          </a:bodyPr>
+          <a:lstStyle/>
+          <a:p>
+            <a:pPr algn="l"/>
+            <a:r>
+              <a:rPr sz="1050" b="0">
+                <a:solidFill>
+                  <a:srgbClr val="5A6878"/>
+                </a:solidFill>
+                <a:latin typeface="Nimbus Sans"/>
+                <a:ea typeface="Nimbus Sans"/>
+                <a:cs typeface="Nimbus Sans"/>
+              </a:rPr>
+              <a:t>Saldo de cartera al cierre de septiembre</a:t>
+            </a:r>
+          </a:p>
+        </p:txBody>
+      </p:sp>
+      <p:sp>
+        <p:nvSpPr>
+          <p:cNvPr id="36" name="TextBox 35"/>
+          <p:cNvSpPr txBox="1"/>
+          <p:nvPr/>
+        </p:nvSpPr>
+        <p:spPr>
+          <a:xfrm>
+            <a:off x="749808" y="5980176"/>
+            <a:ext cx="2743200" cy="228600"/>
+          </a:xfrm>
+          <a:prstGeom prst="rect">
+            <a:avLst/>
+          </a:prstGeom>
+          <a:noFill/>
+        </p:spPr>
+        <p:txBody>
+          <a:bodyPr wrap="square" anchor="t" lIns="0" rIns="0" tIns="0" bIns="0">
+            <a:spAutoFit/>
+          </a:bodyPr>
+          <a:lstStyle/>
+          <a:p>
+            <a:pPr algn="l"/>
+            <a:r>
+              <a:rPr sz="1250" b="0">
+                <a:solidFill>
+                  <a:srgbClr val="5A6878"/>
+                </a:solidFill>
+                <a:latin typeface="Nimbus Sans"/>
+                <a:ea typeface="Nimbus Sans"/>
+                <a:cs typeface="Nimbus Sans"/>
+              </a:rPr>
+              <a:t>$80,151,314.67</a:t>
+            </a:r>
+          </a:p>
+        </p:txBody>
+      </p:sp>
+      <p:sp>
+        <p:nvSpPr>
+          <p:cNvPr id="37" name="TextBox 36"/>
+          <p:cNvSpPr txBox="1"/>
+          <p:nvPr/>
+        </p:nvSpPr>
+        <p:spPr>
+          <a:xfrm>
+            <a:off x="3584448" y="5806440"/>
+            <a:ext cx="2011680" cy="182880"/>
+          </a:xfrm>
+          <a:prstGeom prst="rect">
+            <a:avLst/>
+          </a:prstGeom>
+          <a:noFill/>
+        </p:spPr>
+        <p:txBody>
+          <a:bodyPr wrap="square" anchor="t" lIns="0" rIns="0" tIns="0" bIns="0">
+            <a:spAutoFit/>
+          </a:bodyPr>
+          <a:lstStyle/>
+          <a:p>
+            <a:pPr algn="l"/>
+            <a:r>
+              <a:rPr sz="1050" b="0">
+                <a:solidFill>
+                  <a:srgbClr val="5A6878"/>
+                </a:solidFill>
+                <a:latin typeface="Nimbus Sans"/>
+                <a:ea typeface="Nimbus Sans"/>
+                <a:cs typeface="Nimbus Sans"/>
+              </a:rPr>
+              <a:t>Meta de crecimiento de cartera</a:t>
+            </a:r>
+          </a:p>
+        </p:txBody>
+      </p:sp>
+      <p:sp>
+        <p:nvSpPr>
+          <p:cNvPr id="38" name="TextBox 37"/>
+          <p:cNvSpPr txBox="1"/>
+          <p:nvPr/>
+        </p:nvSpPr>
+        <p:spPr>
+          <a:xfrm>
+            <a:off x="3584448" y="5980176"/>
+            <a:ext cx="2011680" cy="228600"/>
+          </a:xfrm>
+          <a:prstGeom prst="rect">
+            <a:avLst/>
+          </a:prstGeom>
+          <a:noFill/>
+        </p:spPr>
+        <p:txBody>
+          <a:bodyPr wrap="square" anchor="t" lIns="0" rIns="0" tIns="0" bIns="0">
+            <a:spAutoFit/>
+          </a:bodyPr>
+          <a:lstStyle/>
+          <a:p>
+            <a:pPr algn="l"/>
+            <a:r>
+              <a:rPr sz="1250" b="0">
+                <a:solidFill>
+                  <a:srgbClr val="5A6878"/>
+                </a:solidFill>
+                <a:latin typeface="Nimbus Sans"/>
+                <a:ea typeface="Nimbus Sans"/>
+                <a:cs typeface="Nimbus Sans"/>
+              </a:rPr>
+              <a:t>$2,393,084.78</a:t>
+            </a:r>
+          </a:p>
+        </p:txBody>
+      </p:sp>
+      <p:sp>
+        <p:nvSpPr>
+          <p:cNvPr id="39" name="Agencia Colegio Médico"/>
+          <p:cNvSpPr/>
+          <p:nvPr/>
+        </p:nvSpPr>
+        <p:spPr>
+          <a:xfrm>
+            <a:off x="6227064" y="1417320"/>
+            <a:ext cx="5486400" cy="5120640"/>
+          </a:xfrm>
+          <a:prstGeom prst="roundRect">
+            <a:avLst>
+              <a:gd name="adj" fmla="val 4000"/>
+            </a:avLst>
+          </a:prstGeom>
+          <a:solidFill>
+            <a:srgbClr val="F3F6F9"/>
+          </a:solidFill>
+          <a:ln>
+            <a:noFill/>
+          </a:ln>
+        </p:spPr>
+        <p:style>
+          <a:lnRef idx="1">
+            <a:schemeClr val="accent1"/>
+          </a:lnRef>
+          <a:fillRef idx="3">
+            <a:schemeClr val="accent1"/>
+          </a:fillRef>
+          <a:effectRef idx="2">
+            <a:schemeClr val="accent1"/>
+          </a:effectRef>
+          <a:fontRef idx="minor">
+            <a:schemeClr val="lt1"/>
+          </a:fontRef>
+        </p:style>
+        <p:txBody>
+          <a:bodyPr rtlCol="0" anchor="ctr"/>
+          <a:lstStyle/>
+          <a:p>
+            <a:pPr algn="ctr"/>
+          </a:p>
+        </p:txBody>
+      </p:sp>
+      <p:sp>
+        <p:nvSpPr>
+          <p:cNvPr id="40" name="TextBox 39"/>
+          <p:cNvSpPr txBox="1"/>
+          <p:nvPr/>
+        </p:nvSpPr>
+        <p:spPr>
+          <a:xfrm>
+            <a:off x="6501384" y="1600200"/>
+            <a:ext cx="4937760" cy="365760"/>
+          </a:xfrm>
+          <a:prstGeom prst="rect">
+            <a:avLst/>
+          </a:prstGeom>
+          <a:noFill/>
+        </p:spPr>
+        <p:txBody>
+          <a:bodyPr wrap="square" anchor="t" lIns="0" rIns="0" tIns="0" bIns="0">
+            <a:spAutoFit/>
+          </a:bodyPr>
+          <a:lstStyle/>
+          <a:p>
+            <a:pPr algn="l"/>
+            <a:r>
+              <a:rPr sz="2000" b="1">
+                <a:solidFill>
+                  <a:srgbClr val="12304D"/>
+                </a:solidFill>
+                <a:latin typeface="Nimbus Sans"/>
+                <a:ea typeface="Nimbus Sans"/>
+                <a:cs typeface="Nimbus Sans"/>
+              </a:rPr>
+              <a:t>Colegio Médico</a:t>
+            </a:r>
+          </a:p>
+        </p:txBody>
+      </p:sp>
+      <p:sp>
+        <p:nvSpPr>
+          <p:cNvPr id="41" name="Oval 40"/>
+          <p:cNvSpPr/>
+          <p:nvPr/>
+        </p:nvSpPr>
+        <p:spPr>
+          <a:xfrm>
+            <a:off x="6501384" y="2075688"/>
+            <a:ext cx="256032" cy="256032"/>
+          </a:xfrm>
+          <a:prstGeom prst="ellipse">
+            <a:avLst/>
+          </a:prstGeom>
+          <a:solidFill>
+            <a:srgbClr val="12304D"/>
+          </a:solidFill>
+          <a:ln>
+            <a:noFill/>
+          </a:ln>
+        </p:spPr>
+        <p:style>
+          <a:lnRef idx="1">
+            <a:schemeClr val="accent1"/>
+          </a:lnRef>
+          <a:fillRef idx="3">
+            <a:schemeClr val="accent1"/>
+          </a:fillRef>
+          <a:effectRef idx="2">
+            <a:schemeClr val="accent1"/>
+          </a:effectRef>
+          <a:fontRef idx="minor">
+            <a:schemeClr val="lt1"/>
+          </a:fontRef>
+        </p:style>
+        <p:txBody>
+          <a:bodyPr rtlCol="0" anchor="ctr" lIns="0" rIns="0" tIns="0" bIns="0"/>
+          <a:lstStyle/>
+          <a:p>
+            <a:pPr algn="ctr"/>
+            <a:r>
+              <a:rPr sz="1300" b="1">
+                <a:solidFill>
+                  <a:srgbClr val="FFFFFF"/>
+                </a:solidFill>
+                <a:latin typeface="Nimbus Sans"/>
+                <a:ea typeface="Nimbus Sans"/>
+                <a:cs typeface="Nimbus Sans"/>
+              </a:rPr>
+              <a:t>1</a:t>
+            </a:r>
+          </a:p>
+        </p:txBody>
+      </p:sp>
+      <p:sp>
+        <p:nvSpPr>
+          <p:cNvPr id="42" name="TextBox 41"/>
+          <p:cNvSpPr txBox="1"/>
+          <p:nvPr/>
+        </p:nvSpPr>
+        <p:spPr>
+          <a:xfrm>
+            <a:off x="6867144" y="2075688"/>
+            <a:ext cx="4572000" cy="256032"/>
+          </a:xfrm>
+          <a:prstGeom prst="rect">
+            <a:avLst/>
+          </a:prstGeom>
+          <a:noFill/>
+        </p:spPr>
+        <p:txBody>
+          <a:bodyPr wrap="square" anchor="ctr" lIns="0" rIns="0" tIns="0" bIns="0">
+            <a:spAutoFit/>
+          </a:bodyPr>
+          <a:lstStyle/>
+          <a:p>
+            <a:pPr algn="l"/>
+            <a:r>
+              <a:rPr sz="1100" b="1">
+                <a:solidFill>
+                  <a:srgbClr val="2C79A8"/>
+                </a:solidFill>
+                <a:latin typeface="Nimbus Sans"/>
+                <a:ea typeface="Nimbus Sans"/>
+                <a:cs typeface="Nimbus Sans"/>
+              </a:rPr>
+              <a:t>DESEMBOLSOS</a:t>
+            </a:r>
+          </a:p>
+        </p:txBody>
+      </p:sp>
+      <p:sp>
+        <p:nvSpPr>
+          <p:cNvPr id="43" name="TextBox 42"/>
+          <p:cNvSpPr txBox="1"/>
+          <p:nvPr/>
+        </p:nvSpPr>
+        <p:spPr>
+          <a:xfrm>
+            <a:off x="6501384" y="2459736"/>
+            <a:ext cx="2377440" cy="384048"/>
+          </a:xfrm>
+          <a:prstGeom prst="rect">
+            <a:avLst/>
+          </a:prstGeom>
+          <a:noFill/>
+        </p:spPr>
+        <p:txBody>
+          <a:bodyPr wrap="square" anchor="t" lIns="0" rIns="0" tIns="0" bIns="0">
+            <a:spAutoFit/>
+          </a:bodyPr>
+          <a:lstStyle/>
+          <a:p>
+            <a:pPr algn="l"/>
+            <a:r>
+              <a:rPr sz="2400" b="1">
+                <a:solidFill>
+                  <a:srgbClr val="B83B48"/>
+                </a:solidFill>
+                <a:latin typeface="Nimbus Sans"/>
+                <a:ea typeface="Nimbus Sans"/>
+                <a:cs typeface="Nimbus Sans"/>
+              </a:rPr>
+              <a:t>67.41%</a:t>
+            </a:r>
+          </a:p>
+        </p:txBody>
+      </p:sp>
+      <p:sp>
+        <p:nvSpPr>
+          <p:cNvPr id="44" name="TextBox 43"/>
+          <p:cNvSpPr txBox="1"/>
+          <p:nvPr/>
+        </p:nvSpPr>
+        <p:spPr>
+          <a:xfrm>
+            <a:off x="6501384" y="2871216"/>
+            <a:ext cx="2377440" cy="228600"/>
+          </a:xfrm>
+          <a:prstGeom prst="rect">
+            <a:avLst/>
+          </a:prstGeom>
+          <a:noFill/>
+        </p:spPr>
+        <p:txBody>
+          <a:bodyPr wrap="square" anchor="t" lIns="0" rIns="0" tIns="0" bIns="0">
+            <a:spAutoFit/>
+          </a:bodyPr>
+          <a:lstStyle/>
+          <a:p>
+            <a:pPr algn="l"/>
+            <a:r>
+              <a:rPr sz="1050" b="0">
+                <a:solidFill>
+                  <a:srgbClr val="12304D"/>
+                </a:solidFill>
+                <a:latin typeface="Nimbus Sans"/>
+                <a:ea typeface="Nimbus Sans"/>
+                <a:cs typeface="Nimbus Sans"/>
+              </a:rPr>
+              <a:t>Cumplimiento de desembolsos</a:t>
+            </a:r>
+          </a:p>
+        </p:txBody>
+      </p:sp>
+      <p:sp>
+        <p:nvSpPr>
+          <p:cNvPr id="45" name="TextBox 44"/>
+          <p:cNvSpPr txBox="1"/>
+          <p:nvPr/>
+        </p:nvSpPr>
+        <p:spPr>
+          <a:xfrm>
+            <a:off x="9015984" y="2459736"/>
+            <a:ext cx="2423160" cy="182880"/>
+          </a:xfrm>
+          <a:prstGeom prst="rect">
+            <a:avLst/>
+          </a:prstGeom>
+          <a:noFill/>
+        </p:spPr>
+        <p:txBody>
+          <a:bodyPr wrap="square" anchor="t" lIns="0" rIns="0" tIns="0" bIns="0">
+            <a:spAutoFit/>
+          </a:bodyPr>
+          <a:lstStyle/>
+          <a:p>
+            <a:pPr algn="l"/>
+            <a:r>
+              <a:rPr sz="1050" b="0">
+                <a:solidFill>
+                  <a:srgbClr val="5A6878"/>
+                </a:solidFill>
+                <a:latin typeface="Nimbus Sans"/>
+                <a:ea typeface="Nimbus Sans"/>
+                <a:cs typeface="Nimbus Sans"/>
+              </a:rPr>
+              <a:t>Meta de desembolsos</a:t>
+            </a:r>
+          </a:p>
+        </p:txBody>
+      </p:sp>
+      <p:sp>
+        <p:nvSpPr>
+          <p:cNvPr id="46" name="TextBox 45"/>
+          <p:cNvSpPr txBox="1"/>
+          <p:nvPr/>
+        </p:nvSpPr>
+        <p:spPr>
+          <a:xfrm>
+            <a:off x="9015984" y="2633472"/>
+            <a:ext cx="2423160" cy="228600"/>
+          </a:xfrm>
+          <a:prstGeom prst="rect">
+            <a:avLst/>
+          </a:prstGeom>
+          <a:noFill/>
+        </p:spPr>
+        <p:txBody>
+          <a:bodyPr wrap="square" anchor="t" lIns="0" rIns="0" tIns="0" bIns="0">
+            <a:spAutoFit/>
+          </a:bodyPr>
+          <a:lstStyle/>
+          <a:p>
+            <a:pPr algn="l"/>
+            <a:r>
+              <a:rPr sz="1250" b="0">
+                <a:solidFill>
+                  <a:srgbClr val="5A6878"/>
+                </a:solidFill>
+                <a:latin typeface="Nimbus Sans"/>
+                <a:ea typeface="Nimbus Sans"/>
+                <a:cs typeface="Nimbus Sans"/>
+              </a:rPr>
+              <a:t>$5,625,000.00</a:t>
+            </a:r>
+          </a:p>
+        </p:txBody>
+      </p:sp>
+      <p:sp>
+        <p:nvSpPr>
+          <p:cNvPr id="47" name="TextBox 46"/>
+          <p:cNvSpPr txBox="1"/>
+          <p:nvPr/>
+        </p:nvSpPr>
+        <p:spPr>
+          <a:xfrm>
+            <a:off x="9015984" y="2889504"/>
+            <a:ext cx="2423160" cy="182880"/>
+          </a:xfrm>
+          <a:prstGeom prst="rect">
+            <a:avLst/>
+          </a:prstGeom>
+          <a:noFill/>
+        </p:spPr>
+        <p:txBody>
+          <a:bodyPr wrap="square" anchor="t" lIns="0" rIns="0" tIns="0" bIns="0">
+            <a:spAutoFit/>
+          </a:bodyPr>
+          <a:lstStyle/>
+          <a:p>
+            <a:pPr algn="l"/>
+            <a:r>
+              <a:rPr sz="1050" b="0">
+                <a:solidFill>
+                  <a:srgbClr val="5A6878"/>
+                </a:solidFill>
+                <a:latin typeface="Nimbus Sans"/>
+                <a:ea typeface="Nimbus Sans"/>
+                <a:cs typeface="Nimbus Sans"/>
+              </a:rPr>
+              <a:t>Desembolsos realizados (+)</a:t>
+            </a:r>
+          </a:p>
+        </p:txBody>
+      </p:sp>
+      <p:sp>
+        <p:nvSpPr>
+          <p:cNvPr id="48" name="TextBox 47"/>
+          <p:cNvSpPr txBox="1"/>
+          <p:nvPr/>
+        </p:nvSpPr>
+        <p:spPr>
+          <a:xfrm>
+            <a:off x="9015984" y="3063240"/>
+            <a:ext cx="2423160" cy="228600"/>
+          </a:xfrm>
+          <a:prstGeom prst="rect">
+            <a:avLst/>
+          </a:prstGeom>
+          <a:noFill/>
+        </p:spPr>
+        <p:txBody>
+          <a:bodyPr wrap="square" anchor="t" lIns="0" rIns="0" tIns="0" bIns="0">
+            <a:spAutoFit/>
+          </a:bodyPr>
+          <a:lstStyle/>
+          <a:p>
+            <a:pPr algn="l"/>
+            <a:r>
+              <a:rPr sz="1250" b="0">
+                <a:solidFill>
+                  <a:srgbClr val="5A6878"/>
+                </a:solidFill>
+                <a:latin typeface="Nimbus Sans"/>
+                <a:ea typeface="Nimbus Sans"/>
+                <a:cs typeface="Nimbus Sans"/>
+              </a:rPr>
+              <a:t>$3,792,046.74</a:t>
+            </a:r>
+          </a:p>
+        </p:txBody>
+      </p:sp>
+      <p:cxnSp>
+        <p:nvCxnSpPr>
+          <p:cNvPr id="49" name="Connector 48"/>
+          <p:cNvCxnSpPr/>
+          <p:nvPr/>
+        </p:nvCxnSpPr>
+        <p:spPr>
+          <a:xfrm>
+            <a:off x="6501384" y="3282696"/>
+            <a:ext cx="4937760" cy="0"/>
+          </a:xfrm>
+          <a:prstGeom prst="line">
+            <a:avLst/>
+          </a:prstGeom>
+          <a:ln w="9525">
+            <a:solidFill>
+              <a:srgbClr val="DCE3EA"/>
+            </a:solidFill>
+          </a:ln>
+        </p:spPr>
+        <p:style>
+          <a:lnRef idx="2">
+            <a:schemeClr val="accent1"/>
+          </a:lnRef>
+          <a:fillRef idx="0">
+            <a:schemeClr val="accent1"/>
+          </a:fillRef>
+          <a:effectRef idx="1">
+            <a:schemeClr val="accent1"/>
+          </a:effectRef>
+          <a:fontRef idx="minor">
+            <a:schemeClr val="tx1"/>
+          </a:fontRef>
+        </p:style>
+      </p:cxnSp>
+      <p:sp>
+        <p:nvSpPr>
+          <p:cNvPr id="50" name="Oval 49"/>
+          <p:cNvSpPr/>
+          <p:nvPr/>
+        </p:nvSpPr>
+        <p:spPr>
+          <a:xfrm>
+            <a:off x="6501384" y="3401568"/>
+            <a:ext cx="256032" cy="256032"/>
+          </a:xfrm>
+          <a:prstGeom prst="ellipse">
+            <a:avLst/>
+          </a:prstGeom>
+          <a:solidFill>
+            <a:srgbClr val="12304D"/>
+          </a:solidFill>
+          <a:ln>
+            <a:noFill/>
+          </a:ln>
+        </p:spPr>
+        <p:style>
+          <a:lnRef idx="1">
+            <a:schemeClr val="accent1"/>
+          </a:lnRef>
+          <a:fillRef idx="3">
+            <a:schemeClr val="accent1"/>
+          </a:fillRef>
+          <a:effectRef idx="2">
+            <a:schemeClr val="accent1"/>
+          </a:effectRef>
+          <a:fontRef idx="minor">
+            <a:schemeClr val="lt1"/>
+          </a:fontRef>
+        </p:style>
+        <p:txBody>
+          <a:bodyPr rtlCol="0" anchor="ctr" lIns="0" rIns="0" tIns="0" bIns="0"/>
+          <a:lstStyle/>
+          <a:p>
+            <a:pPr algn="ctr"/>
+            <a:r>
+              <a:rPr sz="1300" b="1">
+                <a:solidFill>
+                  <a:srgbClr val="FFFFFF"/>
+                </a:solidFill>
+                <a:latin typeface="Nimbus Sans"/>
+                <a:ea typeface="Nimbus Sans"/>
+                <a:cs typeface="Nimbus Sans"/>
+              </a:rPr>
+              <a:t>2</a:t>
+            </a:r>
+          </a:p>
+        </p:txBody>
+      </p:sp>
+      <p:sp>
+        <p:nvSpPr>
+          <p:cNvPr id="51" name="TextBox 50"/>
+          <p:cNvSpPr txBox="1"/>
+          <p:nvPr/>
+        </p:nvSpPr>
+        <p:spPr>
+          <a:xfrm>
+            <a:off x="6867144" y="3401568"/>
+            <a:ext cx="4572000" cy="256032"/>
+          </a:xfrm>
+          <a:prstGeom prst="rect">
+            <a:avLst/>
+          </a:prstGeom>
+          <a:noFill/>
+        </p:spPr>
+        <p:txBody>
+          <a:bodyPr wrap="square" anchor="ctr" lIns="0" rIns="0" tIns="0" bIns="0">
+            <a:spAutoFit/>
+          </a:bodyPr>
+          <a:lstStyle/>
+          <a:p>
+            <a:pPr algn="l"/>
+            <a:r>
+              <a:rPr sz="1100" b="1">
+                <a:solidFill>
+                  <a:srgbClr val="2C79A8"/>
+                </a:solidFill>
+                <a:latin typeface="Nimbus Sans"/>
+                <a:ea typeface="Nimbus Sans"/>
+                <a:cs typeface="Nimbus Sans"/>
+              </a:rPr>
+              <a:t>COLOCACIÓN NETA</a:t>
+            </a:r>
+          </a:p>
+        </p:txBody>
+      </p:sp>
+      <p:sp>
+        <p:nvSpPr>
+          <p:cNvPr id="52" name="TextBox 51"/>
+          <p:cNvSpPr txBox="1"/>
+          <p:nvPr/>
+        </p:nvSpPr>
+        <p:spPr>
+          <a:xfrm>
+            <a:off x="6501384" y="3785615"/>
+            <a:ext cx="2377440" cy="384048"/>
+          </a:xfrm>
+          <a:prstGeom prst="rect">
+            <a:avLst/>
+          </a:prstGeom>
+          <a:noFill/>
+        </p:spPr>
+        <p:txBody>
+          <a:bodyPr wrap="square" anchor="t" lIns="0" rIns="0" tIns="0" bIns="0">
+            <a:spAutoFit/>
+          </a:bodyPr>
+          <a:lstStyle/>
+          <a:p>
+            <a:pPr algn="l"/>
+            <a:r>
+              <a:rPr sz="2400" b="1">
+                <a:solidFill>
+                  <a:srgbClr val="1F6B4A"/>
+                </a:solidFill>
+                <a:latin typeface="Nimbus Sans"/>
+                <a:ea typeface="Nimbus Sans"/>
+                <a:cs typeface="Nimbus Sans"/>
+              </a:rPr>
+              <a:t>$763,405.55</a:t>
+            </a:r>
+          </a:p>
+        </p:txBody>
+      </p:sp>
+      <p:sp>
+        <p:nvSpPr>
+          <p:cNvPr id="53" name="TextBox 52"/>
+          <p:cNvSpPr txBox="1"/>
+          <p:nvPr/>
+        </p:nvSpPr>
+        <p:spPr>
+          <a:xfrm>
+            <a:off x="6501384" y="4197096"/>
+            <a:ext cx="2377440" cy="228600"/>
+          </a:xfrm>
+          <a:prstGeom prst="rect">
+            <a:avLst/>
+          </a:prstGeom>
+          <a:noFill/>
+        </p:spPr>
+        <p:txBody>
+          <a:bodyPr wrap="square" anchor="t" lIns="0" rIns="0" tIns="0" bIns="0">
+            <a:spAutoFit/>
+          </a:bodyPr>
+          <a:lstStyle/>
+          <a:p>
+            <a:pPr algn="l"/>
+            <a:r>
+              <a:rPr sz="1050" b="0">
+                <a:solidFill>
+                  <a:srgbClr val="12304D"/>
+                </a:solidFill>
+                <a:latin typeface="Nimbus Sans"/>
+                <a:ea typeface="Nimbus Sans"/>
+                <a:cs typeface="Nimbus Sans"/>
+              </a:rPr>
+              <a:t>Colocación Neta de desembolsos</a:t>
+            </a:r>
+          </a:p>
+        </p:txBody>
+      </p:sp>
+      <p:sp>
+        <p:nvSpPr>
+          <p:cNvPr id="54" name="TextBox 53"/>
+          <p:cNvSpPr txBox="1"/>
+          <p:nvPr/>
+        </p:nvSpPr>
+        <p:spPr>
+          <a:xfrm>
+            <a:off x="9015984" y="3785615"/>
+            <a:ext cx="2423160" cy="182880"/>
+          </a:xfrm>
+          <a:prstGeom prst="rect">
+            <a:avLst/>
+          </a:prstGeom>
+          <a:noFill/>
+        </p:spPr>
+        <p:txBody>
+          <a:bodyPr wrap="square" anchor="t" lIns="0" rIns="0" tIns="0" bIns="0">
+            <a:spAutoFit/>
+          </a:bodyPr>
+          <a:lstStyle/>
+          <a:p>
+            <a:pPr algn="l"/>
+            <a:r>
+              <a:rPr sz="1050" b="0">
+                <a:solidFill>
+                  <a:srgbClr val="5A6878"/>
+                </a:solidFill>
+                <a:latin typeface="Nimbus Sans"/>
+                <a:ea typeface="Nimbus Sans"/>
+                <a:cs typeface="Nimbus Sans"/>
+              </a:rPr>
+              <a:t>Amortización natural (−)</a:t>
+            </a:r>
+          </a:p>
+        </p:txBody>
+      </p:sp>
+      <p:sp>
+        <p:nvSpPr>
+          <p:cNvPr id="55" name="TextBox 54"/>
+          <p:cNvSpPr txBox="1"/>
+          <p:nvPr/>
+        </p:nvSpPr>
+        <p:spPr>
+          <a:xfrm>
+            <a:off x="9015984" y="3959352"/>
+            <a:ext cx="2423160" cy="228600"/>
+          </a:xfrm>
+          <a:prstGeom prst="rect">
+            <a:avLst/>
+          </a:prstGeom>
+          <a:noFill/>
+        </p:spPr>
+        <p:txBody>
+          <a:bodyPr wrap="square" anchor="t" lIns="0" rIns="0" tIns="0" bIns="0">
+            <a:spAutoFit/>
+          </a:bodyPr>
+          <a:lstStyle/>
+          <a:p>
+            <a:pPr algn="l"/>
+            <a:r>
+              <a:rPr sz="1250" b="0">
+                <a:solidFill>
+                  <a:srgbClr val="5A6878"/>
+                </a:solidFill>
+                <a:latin typeface="Nimbus Sans"/>
+                <a:ea typeface="Nimbus Sans"/>
+                <a:cs typeface="Nimbus Sans"/>
+              </a:rPr>
+              <a:t>$2,587,564.25</a:t>
+            </a:r>
+          </a:p>
+        </p:txBody>
+      </p:sp>
+      <p:sp>
+        <p:nvSpPr>
+          <p:cNvPr id="56" name="TextBox 55"/>
+          <p:cNvSpPr txBox="1"/>
+          <p:nvPr/>
+        </p:nvSpPr>
+        <p:spPr>
+          <a:xfrm>
+            <a:off x="9015984" y="4215383"/>
+            <a:ext cx="2423160" cy="182880"/>
+          </a:xfrm>
+          <a:prstGeom prst="rect">
+            <a:avLst/>
+          </a:prstGeom>
+          <a:noFill/>
+        </p:spPr>
+        <p:txBody>
+          <a:bodyPr wrap="square" anchor="t" lIns="0" rIns="0" tIns="0" bIns="0">
+            <a:spAutoFit/>
+          </a:bodyPr>
+          <a:lstStyle/>
+          <a:p>
+            <a:pPr algn="l"/>
+            <a:r>
+              <a:rPr sz="1050" b="0">
+                <a:solidFill>
+                  <a:srgbClr val="5A6878"/>
+                </a:solidFill>
+                <a:latin typeface="Nimbus Sans"/>
+                <a:ea typeface="Nimbus Sans"/>
+                <a:cs typeface="Nimbus Sans"/>
+              </a:rPr>
+              <a:t>Cancelaciones anticipadas (−)</a:t>
+            </a:r>
+          </a:p>
+        </p:txBody>
+      </p:sp>
+      <p:sp>
+        <p:nvSpPr>
+          <p:cNvPr id="57" name="TextBox 56"/>
+          <p:cNvSpPr txBox="1"/>
+          <p:nvPr/>
+        </p:nvSpPr>
+        <p:spPr>
+          <a:xfrm>
+            <a:off x="9015984" y="4389120"/>
+            <a:ext cx="2423160" cy="228600"/>
+          </a:xfrm>
+          <a:prstGeom prst="rect">
+            <a:avLst/>
+          </a:prstGeom>
+          <a:noFill/>
+        </p:spPr>
+        <p:txBody>
+          <a:bodyPr wrap="square" anchor="t" lIns="0" rIns="0" tIns="0" bIns="0">
+            <a:spAutoFit/>
+          </a:bodyPr>
+          <a:lstStyle/>
+          <a:p>
+            <a:pPr algn="l"/>
+            <a:r>
+              <a:rPr sz="1250" b="0">
+                <a:solidFill>
+                  <a:srgbClr val="5A6878"/>
+                </a:solidFill>
+                <a:latin typeface="Nimbus Sans"/>
+                <a:ea typeface="Nimbus Sans"/>
+                <a:cs typeface="Nimbus Sans"/>
+              </a:rPr>
+              <a:t>$441,076.94</a:t>
+            </a:r>
+          </a:p>
+        </p:txBody>
+      </p:sp>
+      <p:cxnSp>
+        <p:nvCxnSpPr>
+          <p:cNvPr id="58" name="Connector 57"/>
+          <p:cNvCxnSpPr/>
+          <p:nvPr/>
+        </p:nvCxnSpPr>
+        <p:spPr>
+          <a:xfrm>
+            <a:off x="6501384" y="4608576"/>
+            <a:ext cx="4937760" cy="0"/>
+          </a:xfrm>
+          <a:prstGeom prst="line">
+            <a:avLst/>
+          </a:prstGeom>
+          <a:ln w="9525">
+            <a:solidFill>
+              <a:srgbClr val="DCE3EA"/>
+            </a:solidFill>
+          </a:ln>
+        </p:spPr>
+        <p:style>
+          <a:lnRef idx="2">
+            <a:schemeClr val="accent1"/>
+          </a:lnRef>
+          <a:fillRef idx="0">
+            <a:schemeClr val="accent1"/>
+          </a:fillRef>
+          <a:effectRef idx="1">
+            <a:schemeClr val="accent1"/>
+          </a:effectRef>
+          <a:fontRef idx="minor">
+            <a:schemeClr val="tx1"/>
+          </a:fontRef>
+        </p:style>
+      </p:cxnSp>
+      <p:sp>
+        <p:nvSpPr>
+          <p:cNvPr id="59" name="Oval 58"/>
+          <p:cNvSpPr/>
+          <p:nvPr/>
+        </p:nvSpPr>
+        <p:spPr>
+          <a:xfrm>
+            <a:off x="6501384" y="4727448"/>
+            <a:ext cx="256032" cy="256032"/>
+          </a:xfrm>
+          <a:prstGeom prst="ellipse">
+            <a:avLst/>
+          </a:prstGeom>
+          <a:solidFill>
+            <a:srgbClr val="12304D"/>
+          </a:solidFill>
+          <a:ln>
+            <a:noFill/>
+          </a:ln>
+        </p:spPr>
+        <p:style>
+          <a:lnRef idx="1">
+            <a:schemeClr val="accent1"/>
+          </a:lnRef>
+          <a:fillRef idx="3">
+            <a:schemeClr val="accent1"/>
+          </a:fillRef>
+          <a:effectRef idx="2">
+            <a:schemeClr val="accent1"/>
+          </a:effectRef>
+          <a:fontRef idx="minor">
+            <a:schemeClr val="lt1"/>
+          </a:fontRef>
+        </p:style>
+        <p:txBody>
+          <a:bodyPr rtlCol="0" anchor="ctr" lIns="0" rIns="0" tIns="0" bIns="0"/>
+          <a:lstStyle/>
+          <a:p>
+            <a:pPr algn="ctr"/>
+            <a:r>
+              <a:rPr sz="1300" b="1">
+                <a:solidFill>
+                  <a:srgbClr val="FFFFFF"/>
+                </a:solidFill>
+                <a:latin typeface="Nimbus Sans"/>
+                <a:ea typeface="Nimbus Sans"/>
+                <a:cs typeface="Nimbus Sans"/>
+              </a:rPr>
+              <a:t>3</a:t>
+            </a:r>
+          </a:p>
+        </p:txBody>
+      </p:sp>
+      <p:sp>
+        <p:nvSpPr>
+          <p:cNvPr id="60" name="TextBox 59"/>
+          <p:cNvSpPr txBox="1"/>
+          <p:nvPr/>
+        </p:nvSpPr>
+        <p:spPr>
+          <a:xfrm>
+            <a:off x="6867144" y="4727448"/>
+            <a:ext cx="4572000" cy="256032"/>
+          </a:xfrm>
+          <a:prstGeom prst="rect">
+            <a:avLst/>
+          </a:prstGeom>
+          <a:noFill/>
+        </p:spPr>
+        <p:txBody>
+          <a:bodyPr wrap="square" anchor="ctr" lIns="0" rIns="0" tIns="0" bIns="0">
+            <a:spAutoFit/>
+          </a:bodyPr>
+          <a:lstStyle/>
+          <a:p>
+            <a:pPr algn="l"/>
+            <a:r>
+              <a:rPr sz="1100" b="1">
+                <a:solidFill>
+                  <a:srgbClr val="2C79A8"/>
+                </a:solidFill>
+                <a:latin typeface="Nimbus Sans"/>
+                <a:ea typeface="Nimbus Sans"/>
+                <a:cs typeface="Nimbus Sans"/>
+              </a:rPr>
+              <a:t>CRECIMIENTO DE CARTERA</a:t>
+            </a:r>
+          </a:p>
+        </p:txBody>
+      </p:sp>
+      <p:sp>
+        <p:nvSpPr>
+          <p:cNvPr id="61" name="TextBox 60"/>
+          <p:cNvSpPr txBox="1"/>
+          <p:nvPr/>
+        </p:nvSpPr>
+        <p:spPr>
+          <a:xfrm>
+            <a:off x="6501384" y="5111496"/>
+            <a:ext cx="1554480" cy="292608"/>
+          </a:xfrm>
+          <a:prstGeom prst="rect">
+            <a:avLst/>
+          </a:prstGeom>
+          <a:noFill/>
+        </p:spPr>
+        <p:txBody>
+          <a:bodyPr wrap="square" anchor="t" lIns="0" rIns="0" tIns="0" bIns="0">
+            <a:spAutoFit/>
+          </a:bodyPr>
+          <a:lstStyle/>
+          <a:p>
+            <a:pPr algn="l"/>
+            <a:r>
+              <a:rPr sz="1600" b="1">
+                <a:solidFill>
+                  <a:srgbClr val="B83B48"/>
+                </a:solidFill>
+                <a:latin typeface="Nimbus Sans"/>
+                <a:ea typeface="Nimbus Sans"/>
+                <a:cs typeface="Nimbus Sans"/>
+              </a:rPr>
+              <a:t>−$84,530.22</a:t>
+            </a:r>
+          </a:p>
+        </p:txBody>
+      </p:sp>
+      <p:sp>
+        <p:nvSpPr>
+          <p:cNvPr id="62" name="TextBox 61"/>
+          <p:cNvSpPr txBox="1"/>
+          <p:nvPr/>
+        </p:nvSpPr>
+        <p:spPr>
+          <a:xfrm>
+            <a:off x="6501384" y="5404104"/>
+            <a:ext cx="1536192" cy="329184"/>
+          </a:xfrm>
+          <a:prstGeom prst="rect">
+            <a:avLst/>
+          </a:prstGeom>
+          <a:noFill/>
+        </p:spPr>
+        <p:txBody>
+          <a:bodyPr wrap="square" anchor="t" lIns="0" rIns="0" tIns="0" bIns="0">
+            <a:spAutoFit/>
+          </a:bodyPr>
+          <a:lstStyle/>
+          <a:p>
+            <a:pPr algn="l"/>
+            <a:r>
+              <a:rPr sz="1000" b="0">
+                <a:solidFill>
+                  <a:srgbClr val="12304D"/>
+                </a:solidFill>
+                <a:latin typeface="Nimbus Sans"/>
+                <a:ea typeface="Nimbus Sans"/>
+                <a:cs typeface="Nimbus Sans"/>
+              </a:rPr>
+              <a:t>Crecimiento de cartera</a:t>
+            </a:r>
+          </a:p>
+        </p:txBody>
+      </p:sp>
+      <p:sp>
+        <p:nvSpPr>
+          <p:cNvPr id="63" name="TextBox 62"/>
+          <p:cNvSpPr txBox="1"/>
+          <p:nvPr/>
+        </p:nvSpPr>
+        <p:spPr>
+          <a:xfrm>
+            <a:off x="8147304" y="5111496"/>
+            <a:ext cx="1554480" cy="292608"/>
+          </a:xfrm>
+          <a:prstGeom prst="rect">
+            <a:avLst/>
+          </a:prstGeom>
+          <a:noFill/>
+        </p:spPr>
+        <p:txBody>
+          <a:bodyPr wrap="square" anchor="t" lIns="0" rIns="0" tIns="0" bIns="0">
+            <a:spAutoFit/>
+          </a:bodyPr>
+          <a:lstStyle/>
+          <a:p>
+            <a:pPr algn="l"/>
+            <a:r>
+              <a:rPr sz="1600" b="1">
+                <a:solidFill>
+                  <a:srgbClr val="B83B48"/>
+                </a:solidFill>
+                <a:latin typeface="Nimbus Sans"/>
+                <a:ea typeface="Nimbus Sans"/>
+                <a:cs typeface="Nimbus Sans"/>
+              </a:rPr>
+              <a:t>-9.74%</a:t>
+            </a:r>
+          </a:p>
+        </p:txBody>
+      </p:sp>
+      <p:sp>
+        <p:nvSpPr>
+          <p:cNvPr id="64" name="TextBox 63"/>
+          <p:cNvSpPr txBox="1"/>
+          <p:nvPr/>
+        </p:nvSpPr>
+        <p:spPr>
+          <a:xfrm>
+            <a:off x="8147304" y="5404104"/>
+            <a:ext cx="1536192" cy="329184"/>
+          </a:xfrm>
+          <a:prstGeom prst="rect">
+            <a:avLst/>
+          </a:prstGeom>
+          <a:noFill/>
+        </p:spPr>
+        <p:txBody>
+          <a:bodyPr wrap="square" anchor="t" lIns="0" rIns="0" tIns="0" bIns="0">
+            <a:spAutoFit/>
+          </a:bodyPr>
+          <a:lstStyle/>
+          <a:p>
+            <a:pPr algn="l"/>
+            <a:r>
+              <a:rPr sz="1000" b="0">
+                <a:solidFill>
+                  <a:srgbClr val="12304D"/>
+                </a:solidFill>
+                <a:latin typeface="Nimbus Sans"/>
+                <a:ea typeface="Nimbus Sans"/>
+                <a:cs typeface="Nimbus Sans"/>
+              </a:rPr>
+              <a:t>Cumplimiento de la meta de crecimiento</a:t>
+            </a:r>
+          </a:p>
+        </p:txBody>
+      </p:sp>
+      <p:sp>
+        <p:nvSpPr>
+          <p:cNvPr id="65" name="TextBox 64"/>
+          <p:cNvSpPr txBox="1"/>
+          <p:nvPr/>
+        </p:nvSpPr>
+        <p:spPr>
+          <a:xfrm>
+            <a:off x="9793224" y="5111496"/>
+            <a:ext cx="1554480" cy="292608"/>
+          </a:xfrm>
+          <a:prstGeom prst="rect">
+            <a:avLst/>
+          </a:prstGeom>
+          <a:noFill/>
+        </p:spPr>
+        <p:txBody>
+          <a:bodyPr wrap="square" anchor="t" lIns="0" rIns="0" tIns="0" bIns="0">
+            <a:spAutoFit/>
+          </a:bodyPr>
+          <a:lstStyle/>
+          <a:p>
+            <a:pPr algn="l"/>
+            <a:r>
+              <a:rPr sz="1600" b="1">
+                <a:solidFill>
+                  <a:srgbClr val="B83B48"/>
+                </a:solidFill>
+                <a:latin typeface="Nimbus Sans"/>
+                <a:ea typeface="Nimbus Sans"/>
+                <a:cs typeface="Nimbus Sans"/>
+              </a:rPr>
+              <a:t>−$952,023.45</a:t>
+            </a:r>
+          </a:p>
+        </p:txBody>
+      </p:sp>
+      <p:sp>
+        <p:nvSpPr>
+          <p:cNvPr id="66" name="TextBox 65"/>
+          <p:cNvSpPr txBox="1"/>
+          <p:nvPr/>
+        </p:nvSpPr>
+        <p:spPr>
+          <a:xfrm>
+            <a:off x="9793224" y="5404104"/>
+            <a:ext cx="1536192" cy="329184"/>
+          </a:xfrm>
+          <a:prstGeom prst="rect">
+            <a:avLst/>
+          </a:prstGeom>
+          <a:noFill/>
+        </p:spPr>
+        <p:txBody>
+          <a:bodyPr wrap="square" anchor="t" lIns="0" rIns="0" tIns="0" bIns="0">
+            <a:spAutoFit/>
+          </a:bodyPr>
+          <a:lstStyle/>
+          <a:p>
+            <a:pPr algn="l"/>
+            <a:r>
+              <a:rPr sz="1000" b="0">
+                <a:solidFill>
+                  <a:srgbClr val="12304D"/>
+                </a:solidFill>
+                <a:latin typeface="Nimbus Sans"/>
+                <a:ea typeface="Nimbus Sans"/>
+                <a:cs typeface="Nimbus Sans"/>
+              </a:rPr>
+              <a:t>Déficit de crecimiento de cartera</a:t>
+            </a:r>
+          </a:p>
+        </p:txBody>
+      </p:sp>
+      <p:sp>
+        <p:nvSpPr>
+          <p:cNvPr id="67" name="TextBox 66"/>
+          <p:cNvSpPr txBox="1"/>
+          <p:nvPr/>
+        </p:nvSpPr>
+        <p:spPr>
+          <a:xfrm>
+            <a:off x="6501384" y="5806440"/>
+            <a:ext cx="2743200" cy="182880"/>
+          </a:xfrm>
+          <a:prstGeom prst="rect">
+            <a:avLst/>
+          </a:prstGeom>
+          <a:noFill/>
+        </p:spPr>
+        <p:txBody>
+          <a:bodyPr wrap="square" anchor="t" lIns="0" rIns="0" tIns="0" bIns="0">
+            <a:spAutoFit/>
+          </a:bodyPr>
+          <a:lstStyle/>
+          <a:p>
+            <a:pPr algn="l"/>
+            <a:r>
+              <a:rPr sz="1050" b="0">
+                <a:solidFill>
+                  <a:srgbClr val="5A6878"/>
+                </a:solidFill>
+                <a:latin typeface="Nimbus Sans"/>
+                <a:ea typeface="Nimbus Sans"/>
+                <a:cs typeface="Nimbus Sans"/>
+              </a:rPr>
+              <a:t>Saldo de cartera al cierre de septiembre</a:t>
+            </a:r>
+          </a:p>
+        </p:txBody>
+      </p:sp>
+      <p:sp>
+        <p:nvSpPr>
+          <p:cNvPr id="68" name="TextBox 67"/>
+          <p:cNvSpPr txBox="1"/>
+          <p:nvPr/>
+        </p:nvSpPr>
+        <p:spPr>
+          <a:xfrm>
+            <a:off x="6501384" y="5980176"/>
+            <a:ext cx="2743200" cy="228600"/>
+          </a:xfrm>
+          <a:prstGeom prst="rect">
+            <a:avLst/>
+          </a:prstGeom>
+          <a:noFill/>
+        </p:spPr>
+        <p:txBody>
+          <a:bodyPr wrap="square" anchor="t" lIns="0" rIns="0" tIns="0" bIns="0">
+            <a:spAutoFit/>
+          </a:bodyPr>
+          <a:lstStyle/>
+          <a:p>
+            <a:pPr algn="l"/>
+            <a:r>
+              <a:rPr sz="1250" b="0">
+                <a:solidFill>
+                  <a:srgbClr val="5A6878"/>
+                </a:solidFill>
+                <a:latin typeface="Nimbus Sans"/>
+                <a:ea typeface="Nimbus Sans"/>
+                <a:cs typeface="Nimbus Sans"/>
+              </a:rPr>
+              <a:t>$28,279,390.71</a:t>
+            </a:r>
+          </a:p>
+        </p:txBody>
+      </p:sp>
+      <p:sp>
+        <p:nvSpPr>
+          <p:cNvPr id="69" name="TextBox 68"/>
+          <p:cNvSpPr txBox="1"/>
+          <p:nvPr/>
+        </p:nvSpPr>
+        <p:spPr>
+          <a:xfrm>
+            <a:off x="9336024" y="5806440"/>
+            <a:ext cx="2011680" cy="182880"/>
+          </a:xfrm>
+          <a:prstGeom prst="rect">
+            <a:avLst/>
+          </a:prstGeom>
+          <a:noFill/>
+        </p:spPr>
+        <p:txBody>
+          <a:bodyPr wrap="square" anchor="t" lIns="0" rIns="0" tIns="0" bIns="0">
+            <a:spAutoFit/>
+          </a:bodyPr>
+          <a:lstStyle/>
+          <a:p>
+            <a:pPr algn="l"/>
+            <a:r>
+              <a:rPr sz="1050" b="0">
+                <a:solidFill>
+                  <a:srgbClr val="5A6878"/>
+                </a:solidFill>
+                <a:latin typeface="Nimbus Sans"/>
+                <a:ea typeface="Nimbus Sans"/>
+                <a:cs typeface="Nimbus Sans"/>
+              </a:rPr>
+              <a:t>Meta de crecimiento de cartera</a:t>
+            </a:r>
+          </a:p>
+        </p:txBody>
+      </p:sp>
+      <p:sp>
+        <p:nvSpPr>
+          <p:cNvPr id="70" name="TextBox 69"/>
+          <p:cNvSpPr txBox="1"/>
+          <p:nvPr/>
+        </p:nvSpPr>
+        <p:spPr>
+          <a:xfrm>
+            <a:off x="9336024" y="5980176"/>
+            <a:ext cx="2011680" cy="228600"/>
+          </a:xfrm>
+          <a:prstGeom prst="rect">
+            <a:avLst/>
+          </a:prstGeom>
+          <a:noFill/>
+        </p:spPr>
+        <p:txBody>
+          <a:bodyPr wrap="square" anchor="t" lIns="0" rIns="0" tIns="0" bIns="0">
+            <a:spAutoFit/>
+          </a:bodyPr>
+          <a:lstStyle/>
+          <a:p>
+            <a:pPr algn="l"/>
+            <a:r>
+              <a:rPr sz="1250" b="0">
+                <a:solidFill>
+                  <a:srgbClr val="5A6878"/>
+                </a:solidFill>
+                <a:latin typeface="Nimbus Sans"/>
+                <a:ea typeface="Nimbus Sans"/>
+                <a:cs typeface="Nimbus Sans"/>
+              </a:rPr>
+              <a:t>$867,493.23</a:t>
+            </a:r>
+          </a:p>
+        </p:txBody>
+      </p:sp>
     </p:spTree>
     <p:extLst>
       <p:ext uri="{BB962C8B-B14F-4D97-AF65-F5344CB8AC3E}">

</xml_diff>